<commit_message>
prezentacja - ostateczna wersja
</commit_message>
<xml_diff>
--- a/VoG_Impact_Data_Ranking_presentation.pptx
+++ b/VoG_Impact_Data_Ranking_presentation.pptx
@@ -5,7 +5,7 @@
     <p:sldMasterId id="2147483648" r:id="rId1"/>
   </p:sldMasterIdLst>
   <p:notesMasterIdLst>
-    <p:notesMasterId r:id="rId20"/>
+    <p:notesMasterId r:id="rId18"/>
   </p:notesMasterIdLst>
   <p:sldIdLst>
     <p:sldId id="256" r:id="rId2"/>
@@ -13,19 +13,17 @@
     <p:sldId id="259" r:id="rId4"/>
     <p:sldId id="260" r:id="rId5"/>
     <p:sldId id="261" r:id="rId6"/>
-    <p:sldId id="262" r:id="rId7"/>
+    <p:sldId id="277" r:id="rId7"/>
     <p:sldId id="263" r:id="rId8"/>
     <p:sldId id="264" r:id="rId9"/>
     <p:sldId id="265" r:id="rId10"/>
     <p:sldId id="266" r:id="rId11"/>
     <p:sldId id="267" r:id="rId12"/>
     <p:sldId id="268" r:id="rId13"/>
-    <p:sldId id="272" r:id="rId14"/>
-    <p:sldId id="273" r:id="rId15"/>
-    <p:sldId id="274" r:id="rId16"/>
+    <p:sldId id="275" r:id="rId14"/>
+    <p:sldId id="278" r:id="rId15"/>
+    <p:sldId id="280" r:id="rId16"/>
     <p:sldId id="269" r:id="rId17"/>
-    <p:sldId id="270" r:id="rId18"/>
-    <p:sldId id="271" r:id="rId19"/>
   </p:sldIdLst>
   <p:sldSz cx="12192000" cy="6858000"/>
   <p:notesSz cx="6858000" cy="12192000"/>
@@ -595,7 +593,13 @@
   <p:cSld>
     <p:spTree>
       <p:nvGrpSpPr>
-        <p:cNvPr id="1" name=""/>
+        <p:cNvPr id="1" name="">
+          <a:extLst>
+            <a:ext uri="{FF2B5EF4-FFF2-40B4-BE49-F238E27FC236}">
+              <a16:creationId xmlns:a16="http://schemas.microsoft.com/office/drawing/2014/main" id="{0304EF67-871D-89A7-04BC-9CC962B4A4B5}"/>
+            </a:ext>
+          </a:extLst>
+        </p:cNvPr>
         <p:cNvGrpSpPr/>
         <p:nvPr/>
       </p:nvGrpSpPr>
@@ -609,7 +613,13 @@
       </p:grpSpPr>
       <p:sp>
         <p:nvSpPr>
-          <p:cNvPr id="2" name="Slide Image Placeholder 1"/>
+          <p:cNvPr id="2" name="Slide Image Placeholder 1">
+            <a:extLst>
+              <a:ext uri="{FF2B5EF4-FFF2-40B4-BE49-F238E27FC236}">
+                <a16:creationId xmlns:a16="http://schemas.microsoft.com/office/drawing/2014/main" id="{EB8A2F3E-CA0E-F783-D064-14BF7D2B53B5}"/>
+              </a:ext>
+            </a:extLst>
+          </p:cNvPr>
           <p:cNvSpPr>
             <a:spLocks noGrp="1" noRot="1" noChangeAspect="1"/>
           </p:cNvSpPr>
@@ -621,7 +631,13 @@
       </p:sp>
       <p:sp>
         <p:nvSpPr>
-          <p:cNvPr id="3" name="Notes Placeholder 2"/>
+          <p:cNvPr id="3" name="Notes Placeholder 2">
+            <a:extLst>
+              <a:ext uri="{FF2B5EF4-FFF2-40B4-BE49-F238E27FC236}">
+                <a16:creationId xmlns:a16="http://schemas.microsoft.com/office/drawing/2014/main" id="{6096E144-85D2-1475-9EB0-570E1DD5BC52}"/>
+              </a:ext>
+            </a:extLst>
+          </p:cNvPr>
           <p:cNvSpPr>
             <a:spLocks noGrp="1"/>
           </p:cNvSpPr>
@@ -640,7 +656,13 @@
       </p:sp>
       <p:sp>
         <p:nvSpPr>
-          <p:cNvPr id="4" name="Slide Number Placeholder 3"/>
+          <p:cNvPr id="4" name="Slide Number Placeholder 3">
+            <a:extLst>
+              <a:ext uri="{FF2B5EF4-FFF2-40B4-BE49-F238E27FC236}">
+                <a16:creationId xmlns:a16="http://schemas.microsoft.com/office/drawing/2014/main" id="{E383028B-D8FF-7D7E-040C-A06D305CB14F}"/>
+              </a:ext>
+            </a:extLst>
+          </p:cNvPr>
           <p:cNvSpPr>
             <a:spLocks noGrp="1"/>
           </p:cNvSpPr>
@@ -655,7 +677,7 @@
           <a:p>
             <a:fld id="{F7021451-1387-4CA6-816F-3879F97B5CBC}" type="slidenum">
               <a:rPr lang="en-US"/>
-              <a:t>16</a:t>
+              <a:t>13</a:t>
             </a:fld>
             <a:endParaRPr lang="en-US"/>
           </a:p>
@@ -664,7 +686,7 @@
     </p:spTree>
     <p:extLst>
       <p:ext uri="{BB962C8B-B14F-4D97-AF65-F5344CB8AC3E}">
-        <p14:creationId xmlns:p14="http://schemas.microsoft.com/office/powerpoint/2010/main" val="1024086991"/>
+        <p14:creationId xmlns:p14="http://schemas.microsoft.com/office/powerpoint/2010/main" val="220915549"/>
       </p:ext>
     </p:extLst>
   </p:cSld>
@@ -675,6 +697,222 @@
 </file>
 
 <file path=ppt/notesSlides/notesSlide14.xml><?xml version="1.0" encoding="utf-8"?>
+<p:notes xmlns:a="http://schemas.openxmlformats.org/drawingml/2006/main" xmlns:r="http://schemas.openxmlformats.org/officeDocument/2006/relationships" xmlns:p="http://schemas.openxmlformats.org/presentationml/2006/main">
+  <p:cSld>
+    <p:spTree>
+      <p:nvGrpSpPr>
+        <p:cNvPr id="1" name="">
+          <a:extLst>
+            <a:ext uri="{FF2B5EF4-FFF2-40B4-BE49-F238E27FC236}">
+              <a16:creationId xmlns:a16="http://schemas.microsoft.com/office/drawing/2014/main" id="{93D3B314-E215-BC46-54F8-B1DE9155B26C}"/>
+            </a:ext>
+          </a:extLst>
+        </p:cNvPr>
+        <p:cNvGrpSpPr/>
+        <p:nvPr/>
+      </p:nvGrpSpPr>
+      <p:grpSpPr>
+        <a:xfrm>
+          <a:off x="0" y="0"/>
+          <a:ext cx="0" cy="0"/>
+          <a:chOff x="0" y="0"/>
+          <a:chExt cx="0" cy="0"/>
+        </a:xfrm>
+      </p:grpSpPr>
+      <p:sp>
+        <p:nvSpPr>
+          <p:cNvPr id="2" name="Slide Image Placeholder 1">
+            <a:extLst>
+              <a:ext uri="{FF2B5EF4-FFF2-40B4-BE49-F238E27FC236}">
+                <a16:creationId xmlns:a16="http://schemas.microsoft.com/office/drawing/2014/main" id="{64197347-ED7D-5BB0-B24B-C9C87F5596B9}"/>
+              </a:ext>
+            </a:extLst>
+          </p:cNvPr>
+          <p:cNvSpPr>
+            <a:spLocks noGrp="1" noRot="1" noChangeAspect="1"/>
+          </p:cNvSpPr>
+          <p:nvPr>
+            <p:ph type="sldImg"/>
+          </p:nvPr>
+        </p:nvSpPr>
+        <p:spPr/>
+      </p:sp>
+      <p:sp>
+        <p:nvSpPr>
+          <p:cNvPr id="3" name="Notes Placeholder 2">
+            <a:extLst>
+              <a:ext uri="{FF2B5EF4-FFF2-40B4-BE49-F238E27FC236}">
+                <a16:creationId xmlns:a16="http://schemas.microsoft.com/office/drawing/2014/main" id="{CEB65C11-5DC2-E805-1726-4E36173F5F51}"/>
+              </a:ext>
+            </a:extLst>
+          </p:cNvPr>
+          <p:cNvSpPr>
+            <a:spLocks noGrp="1"/>
+          </p:cNvSpPr>
+          <p:nvPr>
+            <p:ph type="body" idx="1"/>
+          </p:nvPr>
+        </p:nvSpPr>
+        <p:spPr/>
+        <p:txBody>
+          <a:bodyPr/>
+          <a:lstStyle/>
+          <a:p>
+            <a:endParaRPr lang="en-US" dirty="0"/>
+          </a:p>
+        </p:txBody>
+      </p:sp>
+      <p:sp>
+        <p:nvSpPr>
+          <p:cNvPr id="4" name="Slide Number Placeholder 3">
+            <a:extLst>
+              <a:ext uri="{FF2B5EF4-FFF2-40B4-BE49-F238E27FC236}">
+                <a16:creationId xmlns:a16="http://schemas.microsoft.com/office/drawing/2014/main" id="{97ACEF90-0F56-04DB-A9FF-629DC954E47B}"/>
+              </a:ext>
+            </a:extLst>
+          </p:cNvPr>
+          <p:cNvSpPr>
+            <a:spLocks noGrp="1"/>
+          </p:cNvSpPr>
+          <p:nvPr>
+            <p:ph type="sldNum" sz="quarter" idx="10"/>
+          </p:nvPr>
+        </p:nvSpPr>
+        <p:spPr/>
+        <p:txBody>
+          <a:bodyPr/>
+          <a:lstStyle/>
+          <a:p>
+            <a:fld id="{F7021451-1387-4CA6-816F-3879F97B5CBC}" type="slidenum">
+              <a:rPr lang="en-US"/>
+              <a:t>14</a:t>
+            </a:fld>
+            <a:endParaRPr lang="en-US"/>
+          </a:p>
+        </p:txBody>
+      </p:sp>
+    </p:spTree>
+    <p:extLst>
+      <p:ext uri="{BB962C8B-B14F-4D97-AF65-F5344CB8AC3E}">
+        <p14:creationId xmlns:p14="http://schemas.microsoft.com/office/powerpoint/2010/main" val="4123433823"/>
+      </p:ext>
+    </p:extLst>
+  </p:cSld>
+  <p:clrMapOvr>
+    <a:masterClrMapping/>
+  </p:clrMapOvr>
+</p:notes>
+</file>
+
+<file path=ppt/notesSlides/notesSlide15.xml><?xml version="1.0" encoding="utf-8"?>
+<p:notes xmlns:a="http://schemas.openxmlformats.org/drawingml/2006/main" xmlns:r="http://schemas.openxmlformats.org/officeDocument/2006/relationships" xmlns:p="http://schemas.openxmlformats.org/presentationml/2006/main">
+  <p:cSld>
+    <p:spTree>
+      <p:nvGrpSpPr>
+        <p:cNvPr id="1" name="">
+          <a:extLst>
+            <a:ext uri="{FF2B5EF4-FFF2-40B4-BE49-F238E27FC236}">
+              <a16:creationId xmlns:a16="http://schemas.microsoft.com/office/drawing/2014/main" id="{74508311-107A-2C11-C902-F7A6805E6DD2}"/>
+            </a:ext>
+          </a:extLst>
+        </p:cNvPr>
+        <p:cNvGrpSpPr/>
+        <p:nvPr/>
+      </p:nvGrpSpPr>
+      <p:grpSpPr>
+        <a:xfrm>
+          <a:off x="0" y="0"/>
+          <a:ext cx="0" cy="0"/>
+          <a:chOff x="0" y="0"/>
+          <a:chExt cx="0" cy="0"/>
+        </a:xfrm>
+      </p:grpSpPr>
+      <p:sp>
+        <p:nvSpPr>
+          <p:cNvPr id="2" name="Slide Image Placeholder 1">
+            <a:extLst>
+              <a:ext uri="{FF2B5EF4-FFF2-40B4-BE49-F238E27FC236}">
+                <a16:creationId xmlns:a16="http://schemas.microsoft.com/office/drawing/2014/main" id="{F4CFA5F1-689B-998E-12A1-9176C935315D}"/>
+              </a:ext>
+            </a:extLst>
+          </p:cNvPr>
+          <p:cNvSpPr>
+            <a:spLocks noGrp="1" noRot="1" noChangeAspect="1"/>
+          </p:cNvSpPr>
+          <p:nvPr>
+            <p:ph type="sldImg"/>
+          </p:nvPr>
+        </p:nvSpPr>
+        <p:spPr/>
+      </p:sp>
+      <p:sp>
+        <p:nvSpPr>
+          <p:cNvPr id="3" name="Notes Placeholder 2">
+            <a:extLst>
+              <a:ext uri="{FF2B5EF4-FFF2-40B4-BE49-F238E27FC236}">
+                <a16:creationId xmlns:a16="http://schemas.microsoft.com/office/drawing/2014/main" id="{BAACC456-EB13-19EF-B8B5-6EF685E2DD96}"/>
+              </a:ext>
+            </a:extLst>
+          </p:cNvPr>
+          <p:cNvSpPr>
+            <a:spLocks noGrp="1"/>
+          </p:cNvSpPr>
+          <p:nvPr>
+            <p:ph type="body" idx="1"/>
+          </p:nvPr>
+        </p:nvSpPr>
+        <p:spPr/>
+        <p:txBody>
+          <a:bodyPr/>
+          <a:lstStyle/>
+          <a:p>
+            <a:endParaRPr lang="en-US" dirty="0"/>
+          </a:p>
+        </p:txBody>
+      </p:sp>
+      <p:sp>
+        <p:nvSpPr>
+          <p:cNvPr id="4" name="Slide Number Placeholder 3">
+            <a:extLst>
+              <a:ext uri="{FF2B5EF4-FFF2-40B4-BE49-F238E27FC236}">
+                <a16:creationId xmlns:a16="http://schemas.microsoft.com/office/drawing/2014/main" id="{9645BF52-0104-4C2C-53E3-2D8AFE16B406}"/>
+              </a:ext>
+            </a:extLst>
+          </p:cNvPr>
+          <p:cNvSpPr>
+            <a:spLocks noGrp="1"/>
+          </p:cNvSpPr>
+          <p:nvPr>
+            <p:ph type="sldNum" sz="quarter" idx="10"/>
+          </p:nvPr>
+        </p:nvSpPr>
+        <p:spPr/>
+        <p:txBody>
+          <a:bodyPr/>
+          <a:lstStyle/>
+          <a:p>
+            <a:fld id="{F7021451-1387-4CA6-816F-3879F97B5CBC}" type="slidenum">
+              <a:rPr lang="en-US"/>
+              <a:t>15</a:t>
+            </a:fld>
+            <a:endParaRPr lang="en-US"/>
+          </a:p>
+        </p:txBody>
+      </p:sp>
+    </p:spTree>
+    <p:extLst>
+      <p:ext uri="{BB962C8B-B14F-4D97-AF65-F5344CB8AC3E}">
+        <p14:creationId xmlns:p14="http://schemas.microsoft.com/office/powerpoint/2010/main" val="111220607"/>
+      </p:ext>
+    </p:extLst>
+  </p:cSld>
+  <p:clrMapOvr>
+    <a:masterClrMapping/>
+  </p:clrMapOvr>
+</p:notes>
+</file>
+
+<file path=ppt/notesSlides/notesSlide16.xml><?xml version="1.0" encoding="utf-8"?>
 <p:notes xmlns:a="http://schemas.openxmlformats.org/drawingml/2006/main" xmlns:r="http://schemas.openxmlformats.org/officeDocument/2006/relationships" xmlns:p="http://schemas.openxmlformats.org/presentationml/2006/main">
   <p:cSld>
     <p:spTree>
@@ -739,91 +977,7 @@
           <a:p>
             <a:fld id="{F7021451-1387-4CA6-816F-3879F97B5CBC}" type="slidenum">
               <a:rPr lang="en-US"/>
-              <a:t>17</a:t>
-            </a:fld>
-            <a:endParaRPr lang="en-US"/>
-          </a:p>
-        </p:txBody>
-      </p:sp>
-    </p:spTree>
-    <p:extLst>
-      <p:ext uri="{BB962C8B-B14F-4D97-AF65-F5344CB8AC3E}">
-        <p14:creationId xmlns:p14="http://schemas.microsoft.com/office/powerpoint/2010/main" val="1024086991"/>
-      </p:ext>
-    </p:extLst>
-  </p:cSld>
-  <p:clrMapOvr>
-    <a:masterClrMapping/>
-  </p:clrMapOvr>
-</p:notes>
-</file>
-
-<file path=ppt/notesSlides/notesSlide15.xml><?xml version="1.0" encoding="utf-8"?>
-<p:notes xmlns:a="http://schemas.openxmlformats.org/drawingml/2006/main" xmlns:r="http://schemas.openxmlformats.org/officeDocument/2006/relationships" xmlns:p="http://schemas.openxmlformats.org/presentationml/2006/main">
-  <p:cSld>
-    <p:spTree>
-      <p:nvGrpSpPr>
-        <p:cNvPr id="1" name=""/>
-        <p:cNvGrpSpPr/>
-        <p:nvPr/>
-      </p:nvGrpSpPr>
-      <p:grpSpPr>
-        <a:xfrm>
-          <a:off x="0" y="0"/>
-          <a:ext cx="0" cy="0"/>
-          <a:chOff x="0" y="0"/>
-          <a:chExt cx="0" cy="0"/>
-        </a:xfrm>
-      </p:grpSpPr>
-      <p:sp>
-        <p:nvSpPr>
-          <p:cNvPr id="2" name="Slide Image Placeholder 1"/>
-          <p:cNvSpPr>
-            <a:spLocks noGrp="1" noRot="1" noChangeAspect="1"/>
-          </p:cNvSpPr>
-          <p:nvPr>
-            <p:ph type="sldImg"/>
-          </p:nvPr>
-        </p:nvSpPr>
-        <p:spPr/>
-      </p:sp>
-      <p:sp>
-        <p:nvSpPr>
-          <p:cNvPr id="3" name="Notes Placeholder 2"/>
-          <p:cNvSpPr>
-            <a:spLocks noGrp="1"/>
-          </p:cNvSpPr>
-          <p:nvPr>
-            <p:ph type="body" idx="1"/>
-          </p:nvPr>
-        </p:nvSpPr>
-        <p:spPr/>
-        <p:txBody>
-          <a:bodyPr/>
-          <a:lstStyle/>
-          <a:p>
-            <a:endParaRPr lang="en-US" dirty="0"/>
-          </a:p>
-        </p:txBody>
-      </p:sp>
-      <p:sp>
-        <p:nvSpPr>
-          <p:cNvPr id="4" name="Slide Number Placeholder 3"/>
-          <p:cNvSpPr>
-            <a:spLocks noGrp="1"/>
-          </p:cNvSpPr>
-          <p:nvPr>
-            <p:ph type="sldNum" sz="quarter" idx="10"/>
-          </p:nvPr>
-        </p:nvSpPr>
-        <p:spPr/>
-        <p:txBody>
-          <a:bodyPr/>
-          <a:lstStyle/>
-          <a:p>
-            <a:fld id="{F7021451-1387-4CA6-816F-3879F97B5CBC}" type="slidenum">
-              <a:rPr lang="en-US"/>
-              <a:t>18</a:t>
+              <a:t>16</a:t>
             </a:fld>
             <a:endParaRPr lang="en-US"/>
           </a:p>
@@ -1183,7 +1337,13 @@
   <p:cSld>
     <p:spTree>
       <p:nvGrpSpPr>
-        <p:cNvPr id="1" name=""/>
+        <p:cNvPr id="1" name="">
+          <a:extLst>
+            <a:ext uri="{FF2B5EF4-FFF2-40B4-BE49-F238E27FC236}">
+              <a16:creationId xmlns:a16="http://schemas.microsoft.com/office/drawing/2014/main" id="{C290D0C8-3535-1181-C6A1-8E7BCAFF76E5}"/>
+            </a:ext>
+          </a:extLst>
+        </p:cNvPr>
         <p:cNvGrpSpPr/>
         <p:nvPr/>
       </p:nvGrpSpPr>
@@ -1197,7 +1357,13 @@
       </p:grpSpPr>
       <p:sp>
         <p:nvSpPr>
-          <p:cNvPr id="2" name="Slide Image Placeholder 1"/>
+          <p:cNvPr id="2" name="Slide Image Placeholder 1">
+            <a:extLst>
+              <a:ext uri="{FF2B5EF4-FFF2-40B4-BE49-F238E27FC236}">
+                <a16:creationId xmlns:a16="http://schemas.microsoft.com/office/drawing/2014/main" id="{B3D7B947-1FC1-A7D6-8A28-77BAD7EB7DE9}"/>
+              </a:ext>
+            </a:extLst>
+          </p:cNvPr>
           <p:cNvSpPr>
             <a:spLocks noGrp="1" noRot="1" noChangeAspect="1"/>
           </p:cNvSpPr>
@@ -1209,7 +1375,13 @@
       </p:sp>
       <p:sp>
         <p:nvSpPr>
-          <p:cNvPr id="3" name="Notes Placeholder 2"/>
+          <p:cNvPr id="3" name="Notes Placeholder 2">
+            <a:extLst>
+              <a:ext uri="{FF2B5EF4-FFF2-40B4-BE49-F238E27FC236}">
+                <a16:creationId xmlns:a16="http://schemas.microsoft.com/office/drawing/2014/main" id="{C787E439-F8B5-F796-31EF-6A7FF6D630BD}"/>
+              </a:ext>
+            </a:extLst>
+          </p:cNvPr>
           <p:cNvSpPr>
             <a:spLocks noGrp="1"/>
           </p:cNvSpPr>
@@ -1228,7 +1400,13 @@
       </p:sp>
       <p:sp>
         <p:nvSpPr>
-          <p:cNvPr id="4" name="Slide Number Placeholder 3"/>
+          <p:cNvPr id="4" name="Slide Number Placeholder 3">
+            <a:extLst>
+              <a:ext uri="{FF2B5EF4-FFF2-40B4-BE49-F238E27FC236}">
+                <a16:creationId xmlns:a16="http://schemas.microsoft.com/office/drawing/2014/main" id="{FAF4B0A5-8845-BC2A-A86E-339C0DF54971}"/>
+              </a:ext>
+            </a:extLst>
+          </p:cNvPr>
           <p:cNvSpPr>
             <a:spLocks noGrp="1"/>
           </p:cNvSpPr>
@@ -1252,7 +1430,7 @@
     </p:spTree>
     <p:extLst>
       <p:ext uri="{BB962C8B-B14F-4D97-AF65-F5344CB8AC3E}">
-        <p14:creationId xmlns:p14="http://schemas.microsoft.com/office/powerpoint/2010/main" val="1024086991"/>
+        <p14:creationId xmlns:p14="http://schemas.microsoft.com/office/powerpoint/2010/main" val="1333592094"/>
       </p:ext>
     </p:extLst>
   </p:cSld>
@@ -2293,7 +2471,7 @@
         </p:blipFill>
         <p:spPr>
           <a:xfrm>
-            <a:off x="777240" y="1446896"/>
+            <a:off x="822960" y="1994916"/>
             <a:ext cx="7040880" cy="3598448"/>
           </a:xfrm>
           <a:prstGeom prst="rect">
@@ -2309,7 +2487,7 @@
         </p:nvSpPr>
         <p:spPr>
           <a:xfrm>
-            <a:off x="8001000" y="1325880"/>
+            <a:off x="8046720" y="1873900"/>
             <a:ext cx="1448410" cy="632460"/>
           </a:xfrm>
           <a:prstGeom prst="rect">
@@ -2341,7 +2519,7 @@
         </p:nvSpPr>
         <p:spPr>
           <a:xfrm>
-            <a:off x="8055864" y="1362456"/>
+            <a:off x="8101584" y="1910476"/>
             <a:ext cx="1338682" cy="559308"/>
           </a:xfrm>
           <a:prstGeom prst="rect">
@@ -2379,7 +2557,7 @@
         </p:nvSpPr>
         <p:spPr>
           <a:xfrm>
-            <a:off x="9449410" y="1325880"/>
+            <a:off x="9495130" y="1873900"/>
             <a:ext cx="921715" cy="632460"/>
           </a:xfrm>
           <a:prstGeom prst="rect">
@@ -2411,7 +2589,7 @@
         </p:nvSpPr>
         <p:spPr>
           <a:xfrm>
-            <a:off x="9504274" y="1362456"/>
+            <a:off x="9549994" y="1910476"/>
             <a:ext cx="811987" cy="559308"/>
           </a:xfrm>
           <a:prstGeom prst="rect">
@@ -2449,7 +2627,7 @@
         </p:nvSpPr>
         <p:spPr>
           <a:xfrm>
-            <a:off x="10371125" y="1325880"/>
+            <a:off x="10416845" y="1873900"/>
             <a:ext cx="921715" cy="632460"/>
           </a:xfrm>
           <a:prstGeom prst="rect">
@@ -2481,7 +2659,7 @@
         </p:nvSpPr>
         <p:spPr>
           <a:xfrm>
-            <a:off x="10425989" y="1362456"/>
+            <a:off x="10471709" y="1910476"/>
             <a:ext cx="811987" cy="559308"/>
           </a:xfrm>
           <a:prstGeom prst="rect">
@@ -2519,7 +2697,7 @@
         </p:nvSpPr>
         <p:spPr>
           <a:xfrm>
-            <a:off x="8001000" y="1958340"/>
+            <a:off x="8046720" y="2506360"/>
             <a:ext cx="1448410" cy="632460"/>
           </a:xfrm>
           <a:prstGeom prst="rect">
@@ -2551,7 +2729,7 @@
         </p:nvSpPr>
         <p:spPr>
           <a:xfrm>
-            <a:off x="8055864" y="1994916"/>
+            <a:off x="8101584" y="2542936"/>
             <a:ext cx="1338682" cy="559308"/>
           </a:xfrm>
           <a:prstGeom prst="rect">
@@ -2589,7 +2767,7 @@
         </p:nvSpPr>
         <p:spPr>
           <a:xfrm>
-            <a:off x="9449410" y="1958340"/>
+            <a:off x="9495130" y="2506360"/>
             <a:ext cx="921715" cy="632460"/>
           </a:xfrm>
           <a:prstGeom prst="rect">
@@ -2621,7 +2799,7 @@
         </p:nvSpPr>
         <p:spPr>
           <a:xfrm>
-            <a:off x="9504274" y="1994916"/>
+            <a:off x="9549994" y="2542936"/>
             <a:ext cx="811987" cy="559308"/>
           </a:xfrm>
           <a:prstGeom prst="rect">
@@ -2659,7 +2837,7 @@
         </p:nvSpPr>
         <p:spPr>
           <a:xfrm>
-            <a:off x="10371125" y="1958340"/>
+            <a:off x="10416845" y="2506360"/>
             <a:ext cx="921715" cy="632460"/>
           </a:xfrm>
           <a:prstGeom prst="rect">
@@ -2691,7 +2869,7 @@
         </p:nvSpPr>
         <p:spPr>
           <a:xfrm>
-            <a:off x="10425989" y="1994916"/>
+            <a:off x="10471709" y="2542936"/>
             <a:ext cx="811987" cy="559308"/>
           </a:xfrm>
           <a:prstGeom prst="rect">
@@ -2729,7 +2907,7 @@
         </p:nvSpPr>
         <p:spPr>
           <a:xfrm>
-            <a:off x="8001000" y="2590800"/>
+            <a:off x="8046720" y="3138820"/>
             <a:ext cx="1448410" cy="632460"/>
           </a:xfrm>
           <a:prstGeom prst="rect">
@@ -2761,7 +2939,7 @@
         </p:nvSpPr>
         <p:spPr>
           <a:xfrm>
-            <a:off x="8055864" y="2627376"/>
+            <a:off x="8101584" y="3175396"/>
             <a:ext cx="1338682" cy="559308"/>
           </a:xfrm>
           <a:prstGeom prst="rect">
@@ -2799,7 +2977,7 @@
         </p:nvSpPr>
         <p:spPr>
           <a:xfrm>
-            <a:off x="9449410" y="2590800"/>
+            <a:off x="9495130" y="3138820"/>
             <a:ext cx="921715" cy="632460"/>
           </a:xfrm>
           <a:prstGeom prst="rect">
@@ -2831,7 +3009,7 @@
         </p:nvSpPr>
         <p:spPr>
           <a:xfrm>
-            <a:off x="9504274" y="2627376"/>
+            <a:off x="9549994" y="3175396"/>
             <a:ext cx="811987" cy="559308"/>
           </a:xfrm>
           <a:prstGeom prst="rect">
@@ -2869,7 +3047,7 @@
         </p:nvSpPr>
         <p:spPr>
           <a:xfrm>
-            <a:off x="10371125" y="2590800"/>
+            <a:off x="10416845" y="3138820"/>
             <a:ext cx="921715" cy="632460"/>
           </a:xfrm>
           <a:prstGeom prst="rect">
@@ -2901,7 +3079,7 @@
         </p:nvSpPr>
         <p:spPr>
           <a:xfrm>
-            <a:off x="10425989" y="2627376"/>
+            <a:off x="10471709" y="3175396"/>
             <a:ext cx="811987" cy="559308"/>
           </a:xfrm>
           <a:prstGeom prst="rect">
@@ -2939,7 +3117,7 @@
         </p:nvSpPr>
         <p:spPr>
           <a:xfrm>
-            <a:off x="8001000" y="3223260"/>
+            <a:off x="8046720" y="3771280"/>
             <a:ext cx="1448410" cy="632460"/>
           </a:xfrm>
           <a:prstGeom prst="rect">
@@ -2971,7 +3149,7 @@
         </p:nvSpPr>
         <p:spPr>
           <a:xfrm>
-            <a:off x="8055864" y="3259836"/>
+            <a:off x="8101584" y="3807856"/>
             <a:ext cx="1338682" cy="559308"/>
           </a:xfrm>
           <a:prstGeom prst="rect">
@@ -3009,7 +3187,7 @@
         </p:nvSpPr>
         <p:spPr>
           <a:xfrm>
-            <a:off x="9449410" y="3223260"/>
+            <a:off x="9495130" y="3771280"/>
             <a:ext cx="921715" cy="632460"/>
           </a:xfrm>
           <a:prstGeom prst="rect">
@@ -3041,7 +3219,7 @@
         </p:nvSpPr>
         <p:spPr>
           <a:xfrm>
-            <a:off x="9504274" y="3259836"/>
+            <a:off x="9549994" y="3807856"/>
             <a:ext cx="811987" cy="559308"/>
           </a:xfrm>
           <a:prstGeom prst="rect">
@@ -3079,7 +3257,7 @@
         </p:nvSpPr>
         <p:spPr>
           <a:xfrm>
-            <a:off x="10371125" y="3223260"/>
+            <a:off x="10416845" y="3771280"/>
             <a:ext cx="921715" cy="632460"/>
           </a:xfrm>
           <a:prstGeom prst="rect">
@@ -3111,7 +3289,7 @@
         </p:nvSpPr>
         <p:spPr>
           <a:xfrm>
-            <a:off x="10425989" y="3259836"/>
+            <a:off x="10471709" y="3807856"/>
             <a:ext cx="811987" cy="559308"/>
           </a:xfrm>
           <a:prstGeom prst="rect">
@@ -3149,7 +3327,7 @@
         </p:nvSpPr>
         <p:spPr>
           <a:xfrm>
-            <a:off x="8001000" y="3855720"/>
+            <a:off x="8046720" y="4403740"/>
             <a:ext cx="1448410" cy="632460"/>
           </a:xfrm>
           <a:prstGeom prst="rect">
@@ -3181,7 +3359,7 @@
         </p:nvSpPr>
         <p:spPr>
           <a:xfrm>
-            <a:off x="8055864" y="3892296"/>
+            <a:off x="8101584" y="4440316"/>
             <a:ext cx="1338682" cy="559308"/>
           </a:xfrm>
           <a:prstGeom prst="rect">
@@ -3219,7 +3397,7 @@
         </p:nvSpPr>
         <p:spPr>
           <a:xfrm>
-            <a:off x="9449410" y="3855720"/>
+            <a:off x="9495130" y="4403740"/>
             <a:ext cx="921715" cy="632460"/>
           </a:xfrm>
           <a:prstGeom prst="rect">
@@ -3251,7 +3429,7 @@
         </p:nvSpPr>
         <p:spPr>
           <a:xfrm>
-            <a:off x="9504274" y="3892296"/>
+            <a:off x="9549994" y="4440316"/>
             <a:ext cx="811987" cy="559308"/>
           </a:xfrm>
           <a:prstGeom prst="rect">
@@ -3289,7 +3467,7 @@
         </p:nvSpPr>
         <p:spPr>
           <a:xfrm>
-            <a:off x="10371125" y="3855720"/>
+            <a:off x="10416845" y="4403740"/>
             <a:ext cx="921715" cy="632460"/>
           </a:xfrm>
           <a:prstGeom prst="rect">
@@ -3321,7 +3499,7 @@
         </p:nvSpPr>
         <p:spPr>
           <a:xfrm>
-            <a:off x="10425989" y="3892296"/>
+            <a:off x="10471709" y="4440316"/>
             <a:ext cx="811987" cy="559308"/>
           </a:xfrm>
           <a:prstGeom prst="rect">
@@ -3359,7 +3537,7 @@
         </p:nvSpPr>
         <p:spPr>
           <a:xfrm>
-            <a:off x="8001000" y="4488180"/>
+            <a:off x="8046720" y="5036200"/>
             <a:ext cx="1448410" cy="632460"/>
           </a:xfrm>
           <a:prstGeom prst="rect">
@@ -3391,7 +3569,7 @@
         </p:nvSpPr>
         <p:spPr>
           <a:xfrm>
-            <a:off x="8055864" y="4524756"/>
+            <a:off x="8101584" y="5072776"/>
             <a:ext cx="1338682" cy="559308"/>
           </a:xfrm>
           <a:prstGeom prst="rect">
@@ -3429,7 +3607,7 @@
         </p:nvSpPr>
         <p:spPr>
           <a:xfrm>
-            <a:off x="9449410" y="4488180"/>
+            <a:off x="9495130" y="5036200"/>
             <a:ext cx="921715" cy="632460"/>
           </a:xfrm>
           <a:prstGeom prst="rect">
@@ -3461,7 +3639,7 @@
         </p:nvSpPr>
         <p:spPr>
           <a:xfrm>
-            <a:off x="9504274" y="4524756"/>
+            <a:off x="9549994" y="5072776"/>
             <a:ext cx="811987" cy="559308"/>
           </a:xfrm>
           <a:prstGeom prst="rect">
@@ -3499,7 +3677,7 @@
         </p:nvSpPr>
         <p:spPr>
           <a:xfrm>
-            <a:off x="10371125" y="4488180"/>
+            <a:off x="10416845" y="5036200"/>
             <a:ext cx="921715" cy="632460"/>
           </a:xfrm>
           <a:prstGeom prst="rect">
@@ -3531,7 +3709,7 @@
         </p:nvSpPr>
         <p:spPr>
           <a:xfrm>
-            <a:off x="10425989" y="4524756"/>
+            <a:off x="10471709" y="5072776"/>
             <a:ext cx="811987" cy="559308"/>
           </a:xfrm>
           <a:prstGeom prst="rect">
@@ -3757,7 +3935,7 @@
         </p:blipFill>
         <p:spPr>
           <a:xfrm>
-            <a:off x="777240" y="1425921"/>
+            <a:off x="777240" y="1892808"/>
             <a:ext cx="8412480" cy="3914718"/>
           </a:xfrm>
           <a:prstGeom prst="rect">
@@ -3773,7 +3951,7 @@
         </p:nvSpPr>
         <p:spPr>
           <a:xfrm>
-            <a:off x="9555480" y="1325880"/>
+            <a:off x="9555480" y="1792767"/>
             <a:ext cx="1645920" cy="822960"/>
           </a:xfrm>
           <a:prstGeom prst="roundRect">
@@ -3807,7 +3985,7 @@
         </p:nvSpPr>
         <p:spPr>
           <a:xfrm>
-            <a:off x="9628632" y="1435608"/>
+            <a:off x="9628632" y="1902495"/>
             <a:ext cx="1499616" cy="384048"/>
           </a:xfrm>
           <a:prstGeom prst="rect">
@@ -3843,7 +4021,7 @@
         </p:nvSpPr>
         <p:spPr>
           <a:xfrm>
-            <a:off x="9628632" y="1892808"/>
+            <a:off x="9628632" y="2359695"/>
             <a:ext cx="1499616" cy="384048"/>
           </a:xfrm>
           <a:prstGeom prst="rect">
@@ -3893,7 +4071,7 @@
         </p:nvSpPr>
         <p:spPr>
           <a:xfrm>
-            <a:off x="9555480" y="2331720"/>
+            <a:off x="9555480" y="2798607"/>
             <a:ext cx="1645920" cy="822960"/>
           </a:xfrm>
           <a:prstGeom prst="roundRect">
@@ -3927,7 +4105,7 @@
         </p:nvSpPr>
         <p:spPr>
           <a:xfrm>
-            <a:off x="9628632" y="2441448"/>
+            <a:off x="9628632" y="2908335"/>
             <a:ext cx="1499616" cy="384048"/>
           </a:xfrm>
           <a:prstGeom prst="rect">
@@ -3963,7 +4141,7 @@
         </p:nvSpPr>
         <p:spPr>
           <a:xfrm>
-            <a:off x="9628632" y="2898648"/>
+            <a:off x="9628632" y="3365535"/>
             <a:ext cx="1499616" cy="384048"/>
           </a:xfrm>
           <a:prstGeom prst="rect">
@@ -4013,7 +4191,7 @@
         </p:nvSpPr>
         <p:spPr>
           <a:xfrm>
-            <a:off x="9555480" y="3429000"/>
+            <a:off x="9555480" y="3895887"/>
             <a:ext cx="1645920" cy="822960"/>
           </a:xfrm>
           <a:prstGeom prst="roundRect">
@@ -4047,7 +4225,7 @@
         </p:nvSpPr>
         <p:spPr>
           <a:xfrm>
-            <a:off x="9628632" y="3538728"/>
+            <a:off x="9628632" y="4005615"/>
             <a:ext cx="1499616" cy="384048"/>
           </a:xfrm>
           <a:prstGeom prst="rect">
@@ -4083,7 +4261,7 @@
         </p:nvSpPr>
         <p:spPr>
           <a:xfrm>
-            <a:off x="9628632" y="3995928"/>
+            <a:off x="9628632" y="4462815"/>
             <a:ext cx="1499616" cy="384048"/>
           </a:xfrm>
           <a:prstGeom prst="rect">
@@ -4133,7 +4311,7 @@
         </p:nvSpPr>
         <p:spPr>
           <a:xfrm>
-            <a:off x="9555480" y="4434840"/>
+            <a:off x="9555480" y="4901727"/>
             <a:ext cx="1645920" cy="822960"/>
           </a:xfrm>
           <a:prstGeom prst="roundRect">
@@ -4167,7 +4345,7 @@
         </p:nvSpPr>
         <p:spPr>
           <a:xfrm>
-            <a:off x="9628632" y="4544568"/>
+            <a:off x="9628632" y="5011455"/>
             <a:ext cx="1499616" cy="384048"/>
           </a:xfrm>
           <a:prstGeom prst="rect">
@@ -4203,7 +4381,7 @@
         </p:nvSpPr>
         <p:spPr>
           <a:xfrm>
-            <a:off x="9628632" y="5001768"/>
+            <a:off x="9628632" y="5468655"/>
             <a:ext cx="1499616" cy="384048"/>
           </a:xfrm>
           <a:prstGeom prst="rect">
@@ -4569,9 +4747,23 @@
 <file path=ppt/slides/slide13.xml><?xml version="1.0" encoding="utf-8"?>
 <p:sld xmlns:a="http://schemas.openxmlformats.org/drawingml/2006/main" xmlns:r="http://schemas.openxmlformats.org/officeDocument/2006/relationships" xmlns:p="http://schemas.openxmlformats.org/presentationml/2006/main">
   <p:cSld>
+    <p:bg>
+      <p:bgPr>
+        <a:solidFill>
+          <a:srgbClr val="FFFFFF"/>
+        </a:solidFill>
+        <a:effectLst/>
+      </p:bgPr>
+    </p:bg>
     <p:spTree>
       <p:nvGrpSpPr>
-        <p:cNvPr id="1" name=""/>
+        <p:cNvPr id="1" name="">
+          <a:extLst>
+            <a:ext uri="{FF2B5EF4-FFF2-40B4-BE49-F238E27FC236}">
+              <a16:creationId xmlns:a16="http://schemas.microsoft.com/office/drawing/2014/main" id="{2353E48D-42F9-4DFC-44CE-FE5CA4874B20}"/>
+            </a:ext>
+          </a:extLst>
+        </p:cNvPr>
         <p:cNvGrpSpPr/>
         <p:nvPr/>
       </p:nvGrpSpPr>
@@ -4583,12 +4775,303 @@
           <a:chExt cx="0" cy="0"/>
         </a:xfrm>
       </p:grpSpPr>
+      <p:sp>
+        <p:nvSpPr>
+          <p:cNvPr id="2" name="Shape 0">
+            <a:extLst>
+              <a:ext uri="{FF2B5EF4-FFF2-40B4-BE49-F238E27FC236}">
+                <a16:creationId xmlns:a16="http://schemas.microsoft.com/office/drawing/2014/main" id="{8554ECA2-A15F-49D6-49EA-D5C027FD410C}"/>
+              </a:ext>
+            </a:extLst>
+          </p:cNvPr>
+          <p:cNvSpPr/>
+          <p:nvPr/>
+        </p:nvSpPr>
+        <p:spPr>
+          <a:xfrm>
+            <a:off x="594360" y="6473952"/>
+            <a:ext cx="10972800" cy="0"/>
+          </a:xfrm>
+          <a:prstGeom prst="line">
+            <a:avLst/>
+          </a:prstGeom>
+          <a:noFill/>
+          <a:ln w="6350">
+            <a:solidFill>
+              <a:srgbClr val="D1D5DB"/>
+            </a:solidFill>
+            <a:prstDash val="solid"/>
+          </a:ln>
+        </p:spPr>
+        <p:txBody>
+          <a:bodyPr/>
+          <a:lstStyle/>
+          <a:p>
+            <a:endParaRPr lang="pl-PL"/>
+          </a:p>
+        </p:txBody>
+      </p:sp>
+      <p:sp>
+        <p:nvSpPr>
+          <p:cNvPr id="3" name="Text 1">
+            <a:extLst>
+              <a:ext uri="{FF2B5EF4-FFF2-40B4-BE49-F238E27FC236}">
+                <a16:creationId xmlns:a16="http://schemas.microsoft.com/office/drawing/2014/main" id="{F2851AEB-6F62-6962-904C-35011397703F}"/>
+              </a:ext>
+            </a:extLst>
+          </p:cNvPr>
+          <p:cNvSpPr/>
+          <p:nvPr/>
+        </p:nvSpPr>
+        <p:spPr>
+          <a:xfrm>
+            <a:off x="594360" y="292608"/>
+            <a:ext cx="10972800" cy="502920"/>
+          </a:xfrm>
+          <a:prstGeom prst="rect">
+            <a:avLst/>
+          </a:prstGeom>
+          <a:noFill/>
+          <a:ln/>
+        </p:spPr>
+        <p:txBody>
+          <a:bodyPr wrap="square" lIns="0" tIns="0" rIns="0" bIns="0" rtlCol="0" anchor="ctr"/>
+          <a:lstStyle/>
+          <a:p>
+            <a:pPr marL="0" indent="0">
+              <a:buNone/>
+            </a:pPr>
+            <a:r>
+              <a:rPr lang="pl-PL" sz="3000" dirty="0">
+                <a:solidFill>
+                  <a:srgbClr val="000000"/>
+                </a:solidFill>
+                <a:latin typeface="Calibri" pitchFamily="34" charset="0"/>
+                <a:ea typeface="Calibri" pitchFamily="34" charset="-122"/>
+                <a:cs typeface="Calibri" pitchFamily="34" charset="-120"/>
+              </a:rPr>
+              <a:t>Modele trenowane na różnych podzbiorach</a:t>
+            </a:r>
+            <a:endParaRPr lang="en-US" sz="3000" dirty="0"/>
+          </a:p>
+        </p:txBody>
+      </p:sp>
+      <p:sp>
+        <p:nvSpPr>
+          <p:cNvPr id="4" name="Text 2">
+            <a:extLst>
+              <a:ext uri="{FF2B5EF4-FFF2-40B4-BE49-F238E27FC236}">
+                <a16:creationId xmlns:a16="http://schemas.microsoft.com/office/drawing/2014/main" id="{753705D7-A7C0-015E-7CF6-3B3599C6C701}"/>
+              </a:ext>
+            </a:extLst>
+          </p:cNvPr>
+          <p:cNvSpPr/>
+          <p:nvPr/>
+        </p:nvSpPr>
+        <p:spPr>
+          <a:xfrm>
+            <a:off x="603504" y="850392"/>
+            <a:ext cx="10698480" cy="329184"/>
+          </a:xfrm>
+          <a:prstGeom prst="rect">
+            <a:avLst/>
+          </a:prstGeom>
+          <a:noFill/>
+          <a:ln/>
+        </p:spPr>
+        <p:txBody>
+          <a:bodyPr wrap="square" lIns="0" tIns="0" rIns="0" bIns="0" rtlCol="0" anchor="ctr"/>
+          <a:lstStyle/>
+          <a:p>
+            <a:pPr marL="0" indent="0">
+              <a:buNone/>
+            </a:pPr>
+            <a:r>
+              <a:rPr lang="pl-PL" sz="1250" dirty="0">
+                <a:solidFill>
+                  <a:srgbClr val="6B7280"/>
+                </a:solidFill>
+                <a:latin typeface="Calibri" pitchFamily="34" charset="0"/>
+                <a:ea typeface="Calibri" pitchFamily="34" charset="-122"/>
+                <a:cs typeface="Calibri" pitchFamily="34" charset="-120"/>
+              </a:rPr>
+              <a:t>Trenowanie modelu na przykładach z wyższym </a:t>
+            </a:r>
+            <a:r>
+              <a:rPr lang="pl-PL" sz="1250" dirty="0" err="1">
+                <a:solidFill>
+                  <a:srgbClr val="6B7280"/>
+                </a:solidFill>
+                <a:latin typeface="Calibri" pitchFamily="34" charset="0"/>
+                <a:ea typeface="Calibri" pitchFamily="34" charset="-122"/>
+                <a:cs typeface="Calibri" pitchFamily="34" charset="-120"/>
+              </a:rPr>
+              <a:t>VoG</a:t>
+            </a:r>
+            <a:r>
+              <a:rPr lang="pl-PL" sz="1250" dirty="0">
+                <a:solidFill>
+                  <a:srgbClr val="6B7280"/>
+                </a:solidFill>
+                <a:latin typeface="Calibri" pitchFamily="34" charset="0"/>
+                <a:ea typeface="Calibri" pitchFamily="34" charset="-122"/>
+                <a:cs typeface="Calibri" pitchFamily="34" charset="-120"/>
+              </a:rPr>
+              <a:t> powodowało jego lepszy performance na danych testowych w 3 na 4 badanych przypadkach.</a:t>
+            </a:r>
+            <a:endParaRPr lang="en-US" sz="1250" dirty="0"/>
+          </a:p>
+        </p:txBody>
+      </p:sp>
+      <p:sp>
+        <p:nvSpPr>
+          <p:cNvPr id="6" name="Shape 3">
+            <a:extLst>
+              <a:ext uri="{FF2B5EF4-FFF2-40B4-BE49-F238E27FC236}">
+                <a16:creationId xmlns:a16="http://schemas.microsoft.com/office/drawing/2014/main" id="{47F0AFCC-D4E7-E15F-0125-157B14F2F568}"/>
+              </a:ext>
+            </a:extLst>
+          </p:cNvPr>
+          <p:cNvSpPr/>
+          <p:nvPr/>
+        </p:nvSpPr>
+        <p:spPr>
+          <a:xfrm>
+            <a:off x="1143000" y="5650992"/>
+            <a:ext cx="9875520" cy="530352"/>
+          </a:xfrm>
+          <a:prstGeom prst="roundRect">
+            <a:avLst>
+              <a:gd name="adj" fmla="val 13793"/>
+            </a:avLst>
+          </a:prstGeom>
+          <a:solidFill>
+            <a:srgbClr val="F9FAFB"/>
+          </a:solidFill>
+          <a:ln w="7620">
+            <a:solidFill>
+              <a:srgbClr val="D1D5DB"/>
+            </a:solidFill>
+            <a:prstDash val="solid"/>
+          </a:ln>
+        </p:spPr>
+        <p:txBody>
+          <a:bodyPr/>
+          <a:lstStyle/>
+          <a:p>
+            <a:endParaRPr lang="pl-PL"/>
+          </a:p>
+        </p:txBody>
+      </p:sp>
+      <p:sp>
+        <p:nvSpPr>
+          <p:cNvPr id="7" name="Text 4">
+            <a:extLst>
+              <a:ext uri="{FF2B5EF4-FFF2-40B4-BE49-F238E27FC236}">
+                <a16:creationId xmlns:a16="http://schemas.microsoft.com/office/drawing/2014/main" id="{C7DEE78E-8E21-4A10-67BB-880A7ADCF67A}"/>
+              </a:ext>
+            </a:extLst>
+          </p:cNvPr>
+          <p:cNvSpPr/>
+          <p:nvPr/>
+        </p:nvSpPr>
+        <p:spPr>
+          <a:xfrm>
+            <a:off x="1325880" y="5797296"/>
+            <a:ext cx="9509760" cy="182880"/>
+          </a:xfrm>
+          <a:prstGeom prst="rect">
+            <a:avLst/>
+          </a:prstGeom>
+          <a:noFill/>
+          <a:ln/>
+        </p:spPr>
+        <p:txBody>
+          <a:bodyPr wrap="square" lIns="0" tIns="0" rIns="0" bIns="0" rtlCol="0" anchor="ctr"/>
+          <a:lstStyle/>
+          <a:p>
+            <a:pPr marL="0" indent="0" algn="ctr">
+              <a:buNone/>
+            </a:pPr>
+            <a:r>
+              <a:rPr lang="pl-PL" sz="1300" dirty="0">
+                <a:solidFill>
+                  <a:srgbClr val="111827"/>
+                </a:solidFill>
+              </a:rPr>
+              <a:t>Jeśli mamy przeprowadzać trening na zbiorze danych o ograniczonej wielkości, lepiej wybrać dane z wyższym </a:t>
+            </a:r>
+            <a:r>
+              <a:rPr lang="pl-PL" sz="1300" dirty="0" err="1">
+                <a:solidFill>
+                  <a:srgbClr val="111827"/>
+                </a:solidFill>
+              </a:rPr>
+              <a:t>VoG</a:t>
+            </a:r>
+            <a:r>
+              <a:rPr lang="pl-PL" sz="1300" dirty="0">
+                <a:solidFill>
+                  <a:srgbClr val="111827"/>
+                </a:solidFill>
+              </a:rPr>
+              <a:t>.</a:t>
+            </a:r>
+            <a:endParaRPr lang="en-US" sz="1300" dirty="0"/>
+          </a:p>
+        </p:txBody>
+      </p:sp>
+      <p:sp>
+        <p:nvSpPr>
+          <p:cNvPr id="9" name="Text 6">
+            <a:extLst>
+              <a:ext uri="{FF2B5EF4-FFF2-40B4-BE49-F238E27FC236}">
+                <a16:creationId xmlns:a16="http://schemas.microsoft.com/office/drawing/2014/main" id="{8790A49B-B62B-E4BA-9E01-C782CF28BC17}"/>
+              </a:ext>
+            </a:extLst>
+          </p:cNvPr>
+          <p:cNvSpPr/>
+          <p:nvPr/>
+        </p:nvSpPr>
+        <p:spPr>
+          <a:xfrm>
+            <a:off x="11338560" y="6547104"/>
+            <a:ext cx="274320" cy="164592"/>
+          </a:xfrm>
+          <a:prstGeom prst="rect">
+            <a:avLst/>
+          </a:prstGeom>
+          <a:noFill/>
+          <a:ln/>
+        </p:spPr>
+        <p:txBody>
+          <a:bodyPr wrap="square" lIns="0" tIns="0" rIns="0" bIns="0" rtlCol="0" anchor="ctr"/>
+          <a:lstStyle/>
+          <a:p>
+            <a:pPr marL="0" indent="0" algn="r">
+              <a:buNone/>
+            </a:pPr>
+            <a:r>
+              <a:rPr lang="en-US" sz="780" dirty="0">
+                <a:solidFill>
+                  <a:srgbClr val="6B7280"/>
+                </a:solidFill>
+                <a:latin typeface="Calibri" pitchFamily="34" charset="0"/>
+                <a:ea typeface="Calibri" pitchFamily="34" charset="-122"/>
+                <a:cs typeface="Calibri" pitchFamily="34" charset="-120"/>
+              </a:rPr>
+              <a:t>13</a:t>
+            </a:r>
+            <a:endParaRPr lang="en-US" sz="780" dirty="0"/>
+          </a:p>
+        </p:txBody>
+      </p:sp>
       <p:pic>
         <p:nvPicPr>
-          <p:cNvPr id="2" name="Obraz 1">
+          <p:cNvPr id="8" name="Obraz 7">
             <a:extLst>
               <a:ext uri="{FF2B5EF4-FFF2-40B4-BE49-F238E27FC236}">
-                <a16:creationId xmlns:a16="http://schemas.microsoft.com/office/drawing/2014/main" id="{8CA9FDB4-BD61-9DB4-5ECB-07C14167FCEF}"/>
+                <a16:creationId xmlns:a16="http://schemas.microsoft.com/office/drawing/2014/main" id="{1CFB1AD0-561F-C472-0BC4-12FD25D645EF}"/>
               </a:ext>
             </a:extLst>
           </p:cNvPr>
@@ -4598,15 +5081,15 @@
           <p:nvPr/>
         </p:nvPicPr>
         <p:blipFill>
-          <a:blip r:embed="rId2"/>
+          <a:blip r:embed="rId3"/>
           <a:stretch>
             <a:fillRect/>
           </a:stretch>
         </p:blipFill>
         <p:spPr>
           <a:xfrm>
-            <a:off x="1709927" y="1240644"/>
-            <a:ext cx="9074847" cy="3379481"/>
+            <a:off x="872617" y="1387910"/>
+            <a:ext cx="10416286" cy="3879034"/>
           </a:xfrm>
           <a:prstGeom prst="rect">
             <a:avLst/>
@@ -4616,7 +5099,7 @@
     </p:spTree>
     <p:extLst>
       <p:ext uri="{BB962C8B-B14F-4D97-AF65-F5344CB8AC3E}">
-        <p14:creationId xmlns:p14="http://schemas.microsoft.com/office/powerpoint/2010/main" val="3620270469"/>
+        <p14:creationId xmlns:p14="http://schemas.microsoft.com/office/powerpoint/2010/main" val="1647841775"/>
       </p:ext>
     </p:extLst>
   </p:cSld>
@@ -4629,9 +5112,23 @@
 <file path=ppt/slides/slide14.xml><?xml version="1.0" encoding="utf-8"?>
 <p:sld xmlns:a="http://schemas.openxmlformats.org/drawingml/2006/main" xmlns:r="http://schemas.openxmlformats.org/officeDocument/2006/relationships" xmlns:p="http://schemas.openxmlformats.org/presentationml/2006/main">
   <p:cSld>
+    <p:bg>
+      <p:bgPr>
+        <a:solidFill>
+          <a:srgbClr val="FFFFFF"/>
+        </a:solidFill>
+        <a:effectLst/>
+      </p:bgPr>
+    </p:bg>
     <p:spTree>
       <p:nvGrpSpPr>
-        <p:cNvPr id="1" name=""/>
+        <p:cNvPr id="1" name="">
+          <a:extLst>
+            <a:ext uri="{FF2B5EF4-FFF2-40B4-BE49-F238E27FC236}">
+              <a16:creationId xmlns:a16="http://schemas.microsoft.com/office/drawing/2014/main" id="{E6B144FB-5E9D-0821-BB2C-049873B7F0BE}"/>
+            </a:ext>
+          </a:extLst>
+        </p:cNvPr>
         <p:cNvGrpSpPr/>
         <p:nvPr/>
       </p:nvGrpSpPr>
@@ -4643,9 +5140,190 @@
           <a:chExt cx="0" cy="0"/>
         </a:xfrm>
       </p:grpSpPr>
+      <p:sp>
+        <p:nvSpPr>
+          <p:cNvPr id="2" name="Shape 0">
+            <a:extLst>
+              <a:ext uri="{FF2B5EF4-FFF2-40B4-BE49-F238E27FC236}">
+                <a16:creationId xmlns:a16="http://schemas.microsoft.com/office/drawing/2014/main" id="{09D44E08-73D5-F1EF-51D0-352441857584}"/>
+              </a:ext>
+            </a:extLst>
+          </p:cNvPr>
+          <p:cNvSpPr/>
+          <p:nvPr/>
+        </p:nvSpPr>
+        <p:spPr>
+          <a:xfrm>
+            <a:off x="594360" y="6473952"/>
+            <a:ext cx="10972800" cy="0"/>
+          </a:xfrm>
+          <a:prstGeom prst="line">
+            <a:avLst/>
+          </a:prstGeom>
+          <a:noFill/>
+          <a:ln w="6350">
+            <a:solidFill>
+              <a:srgbClr val="D1D5DB"/>
+            </a:solidFill>
+            <a:prstDash val="solid"/>
+          </a:ln>
+        </p:spPr>
+        <p:txBody>
+          <a:bodyPr/>
+          <a:lstStyle/>
+          <a:p>
+            <a:endParaRPr lang="pl-PL"/>
+          </a:p>
+        </p:txBody>
+      </p:sp>
+      <p:sp>
+        <p:nvSpPr>
+          <p:cNvPr id="3" name="Text 1">
+            <a:extLst>
+              <a:ext uri="{FF2B5EF4-FFF2-40B4-BE49-F238E27FC236}">
+                <a16:creationId xmlns:a16="http://schemas.microsoft.com/office/drawing/2014/main" id="{5F0DDCA0-13B8-E945-37E7-DA332378F633}"/>
+              </a:ext>
+            </a:extLst>
+          </p:cNvPr>
+          <p:cNvSpPr/>
+          <p:nvPr/>
+        </p:nvSpPr>
+        <p:spPr>
+          <a:xfrm>
+            <a:off x="594360" y="292608"/>
+            <a:ext cx="10972800" cy="502920"/>
+          </a:xfrm>
+          <a:prstGeom prst="rect">
+            <a:avLst/>
+          </a:prstGeom>
+          <a:noFill/>
+          <a:ln/>
+        </p:spPr>
+        <p:txBody>
+          <a:bodyPr wrap="square" lIns="0" tIns="0" rIns="0" bIns="0" rtlCol="0" anchor="ctr"/>
+          <a:lstStyle/>
+          <a:p>
+            <a:pPr marL="0" indent="0">
+              <a:buNone/>
+            </a:pPr>
+            <a:r>
+              <a:rPr lang="pl-PL" sz="3000" dirty="0">
+                <a:solidFill>
+                  <a:srgbClr val="000000"/>
+                </a:solidFill>
+                <a:latin typeface="Calibri" pitchFamily="34" charset="0"/>
+                <a:ea typeface="Calibri" pitchFamily="34" charset="-122"/>
+                <a:cs typeface="Calibri" pitchFamily="34" charset="-120"/>
+              </a:rPr>
+              <a:t>Porównanie próbek: High </a:t>
+            </a:r>
+            <a:r>
+              <a:rPr lang="pl-PL" sz="3000" dirty="0" err="1">
+                <a:solidFill>
+                  <a:srgbClr val="000000"/>
+                </a:solidFill>
+                <a:latin typeface="Calibri" pitchFamily="34" charset="0"/>
+                <a:ea typeface="Calibri" pitchFamily="34" charset="-122"/>
+                <a:cs typeface="Calibri" pitchFamily="34" charset="-120"/>
+              </a:rPr>
+              <a:t>VoG</a:t>
+            </a:r>
+            <a:r>
+              <a:rPr lang="pl-PL" sz="3000" dirty="0">
+                <a:solidFill>
+                  <a:srgbClr val="000000"/>
+                </a:solidFill>
+                <a:latin typeface="Calibri" pitchFamily="34" charset="0"/>
+                <a:ea typeface="Calibri" pitchFamily="34" charset="-122"/>
+                <a:cs typeface="Calibri" pitchFamily="34" charset="-120"/>
+              </a:rPr>
+              <a:t> vs </a:t>
+            </a:r>
+            <a:r>
+              <a:rPr lang="pl-PL" sz="3000" dirty="0" err="1">
+                <a:solidFill>
+                  <a:srgbClr val="000000"/>
+                </a:solidFill>
+                <a:latin typeface="Calibri" pitchFamily="34" charset="0"/>
+                <a:ea typeface="Calibri" pitchFamily="34" charset="-122"/>
+                <a:cs typeface="Calibri" pitchFamily="34" charset="-120"/>
+              </a:rPr>
+              <a:t>Low</a:t>
+            </a:r>
+            <a:r>
+              <a:rPr lang="pl-PL" sz="3000" dirty="0">
+                <a:solidFill>
+                  <a:srgbClr val="000000"/>
+                </a:solidFill>
+                <a:latin typeface="Calibri" pitchFamily="34" charset="0"/>
+                <a:ea typeface="Calibri" pitchFamily="34" charset="-122"/>
+                <a:cs typeface="Calibri" pitchFamily="34" charset="-120"/>
+              </a:rPr>
+              <a:t> </a:t>
+            </a:r>
+            <a:r>
+              <a:rPr lang="pl-PL" sz="3000" dirty="0" err="1">
+                <a:solidFill>
+                  <a:srgbClr val="000000"/>
+                </a:solidFill>
+                <a:latin typeface="Calibri" pitchFamily="34" charset="0"/>
+                <a:ea typeface="Calibri" pitchFamily="34" charset="-122"/>
+                <a:cs typeface="Calibri" pitchFamily="34" charset="-120"/>
+              </a:rPr>
+              <a:t>VoG</a:t>
+            </a:r>
+            <a:endParaRPr lang="en-US" sz="3000" dirty="0"/>
+          </a:p>
+        </p:txBody>
+      </p:sp>
+      <p:sp>
+        <p:nvSpPr>
+          <p:cNvPr id="9" name="Text 6">
+            <a:extLst>
+              <a:ext uri="{FF2B5EF4-FFF2-40B4-BE49-F238E27FC236}">
+                <a16:creationId xmlns:a16="http://schemas.microsoft.com/office/drawing/2014/main" id="{F18B2676-835D-40FE-BD98-69677D7A4FF8}"/>
+              </a:ext>
+            </a:extLst>
+          </p:cNvPr>
+          <p:cNvSpPr/>
+          <p:nvPr/>
+        </p:nvSpPr>
+        <p:spPr>
+          <a:xfrm>
+            <a:off x="11338560" y="6547104"/>
+            <a:ext cx="274320" cy="164592"/>
+          </a:xfrm>
+          <a:prstGeom prst="rect">
+            <a:avLst/>
+          </a:prstGeom>
+          <a:noFill/>
+          <a:ln/>
+        </p:spPr>
+        <p:txBody>
+          <a:bodyPr wrap="square" lIns="0" tIns="0" rIns="0" bIns="0" rtlCol="0" anchor="ctr"/>
+          <a:lstStyle/>
+          <a:p>
+            <a:pPr marL="0" indent="0" algn="r">
+              <a:buNone/>
+            </a:pPr>
+            <a:r>
+              <a:rPr lang="en-US" sz="780" dirty="0">
+                <a:solidFill>
+                  <a:srgbClr val="6B7280"/>
+                </a:solidFill>
+                <a:latin typeface="Calibri" pitchFamily="34" charset="0"/>
+                <a:ea typeface="Calibri" pitchFamily="34" charset="-122"/>
+                <a:cs typeface="Calibri" pitchFamily="34" charset="-120"/>
+              </a:rPr>
+              <a:t>6</a:t>
+            </a:r>
+            <a:endParaRPr lang="en-US" sz="780" dirty="0"/>
+          </a:p>
+        </p:txBody>
+      </p:sp>
       <p:pic>
         <p:nvPicPr>
-          <p:cNvPr id="3" name="Obraz 2">
+          <p:cNvPr id="8" name="Obraz 7">
             <a:extLst>
               <a:ext uri="{FF2B5EF4-FFF2-40B4-BE49-F238E27FC236}">
                 <a16:creationId xmlns:a16="http://schemas.microsoft.com/office/drawing/2014/main" id="{75AF213E-3226-6A9A-5E51-ED9689A18B5C}"/>
@@ -4658,15 +5336,15 @@
           <p:nvPr/>
         </p:nvPicPr>
         <p:blipFill>
-          <a:blip r:embed="rId2"/>
+          <a:blip r:embed="rId3"/>
           <a:stretch>
             <a:fillRect/>
           </a:stretch>
         </p:blipFill>
         <p:spPr>
           <a:xfrm>
-            <a:off x="1224232" y="0"/>
-            <a:ext cx="9743536" cy="6858000"/>
+            <a:off x="1991839" y="878127"/>
+            <a:ext cx="8177841" cy="5755984"/>
           </a:xfrm>
           <a:prstGeom prst="rect">
             <a:avLst/>
@@ -4676,7 +5354,7 @@
     </p:spTree>
     <p:extLst>
       <p:ext uri="{BB962C8B-B14F-4D97-AF65-F5344CB8AC3E}">
-        <p14:creationId xmlns:p14="http://schemas.microsoft.com/office/powerpoint/2010/main" val="835897879"/>
+        <p14:creationId xmlns:p14="http://schemas.microsoft.com/office/powerpoint/2010/main" val="3268859155"/>
       </p:ext>
     </p:extLst>
   </p:cSld>
@@ -4689,9 +5367,23 @@
 <file path=ppt/slides/slide15.xml><?xml version="1.0" encoding="utf-8"?>
 <p:sld xmlns:a="http://schemas.openxmlformats.org/drawingml/2006/main" xmlns:r="http://schemas.openxmlformats.org/officeDocument/2006/relationships" xmlns:p="http://schemas.openxmlformats.org/presentationml/2006/main">
   <p:cSld>
+    <p:bg>
+      <p:bgPr>
+        <a:solidFill>
+          <a:srgbClr val="FFFFFF"/>
+        </a:solidFill>
+        <a:effectLst/>
+      </p:bgPr>
+    </p:bg>
     <p:spTree>
       <p:nvGrpSpPr>
-        <p:cNvPr id="1" name=""/>
+        <p:cNvPr id="1" name="">
+          <a:extLst>
+            <a:ext uri="{FF2B5EF4-FFF2-40B4-BE49-F238E27FC236}">
+              <a16:creationId xmlns:a16="http://schemas.microsoft.com/office/drawing/2014/main" id="{C1D67094-084E-4B9A-650D-53F5B7B9A6FC}"/>
+            </a:ext>
+          </a:extLst>
+        </p:cNvPr>
         <p:cNvGrpSpPr/>
         <p:nvPr/>
       </p:nvGrpSpPr>
@@ -4703,9 +5395,190 @@
           <a:chExt cx="0" cy="0"/>
         </a:xfrm>
       </p:grpSpPr>
+      <p:sp>
+        <p:nvSpPr>
+          <p:cNvPr id="2" name="Shape 0">
+            <a:extLst>
+              <a:ext uri="{FF2B5EF4-FFF2-40B4-BE49-F238E27FC236}">
+                <a16:creationId xmlns:a16="http://schemas.microsoft.com/office/drawing/2014/main" id="{7A8FB292-62F0-BDA1-EC0B-60EFCB2F9544}"/>
+              </a:ext>
+            </a:extLst>
+          </p:cNvPr>
+          <p:cNvSpPr/>
+          <p:nvPr/>
+        </p:nvSpPr>
+        <p:spPr>
+          <a:xfrm>
+            <a:off x="594360" y="6473952"/>
+            <a:ext cx="10972800" cy="0"/>
+          </a:xfrm>
+          <a:prstGeom prst="line">
+            <a:avLst/>
+          </a:prstGeom>
+          <a:noFill/>
+          <a:ln w="6350">
+            <a:solidFill>
+              <a:srgbClr val="D1D5DB"/>
+            </a:solidFill>
+            <a:prstDash val="solid"/>
+          </a:ln>
+        </p:spPr>
+        <p:txBody>
+          <a:bodyPr/>
+          <a:lstStyle/>
+          <a:p>
+            <a:endParaRPr lang="pl-PL"/>
+          </a:p>
+        </p:txBody>
+      </p:sp>
+      <p:sp>
+        <p:nvSpPr>
+          <p:cNvPr id="3" name="Text 1">
+            <a:extLst>
+              <a:ext uri="{FF2B5EF4-FFF2-40B4-BE49-F238E27FC236}">
+                <a16:creationId xmlns:a16="http://schemas.microsoft.com/office/drawing/2014/main" id="{CECAE068-C8F8-0B51-EBBA-F9D0F3FE28CB}"/>
+              </a:ext>
+            </a:extLst>
+          </p:cNvPr>
+          <p:cNvSpPr/>
+          <p:nvPr/>
+        </p:nvSpPr>
+        <p:spPr>
+          <a:xfrm>
+            <a:off x="594360" y="292608"/>
+            <a:ext cx="10972800" cy="502920"/>
+          </a:xfrm>
+          <a:prstGeom prst="rect">
+            <a:avLst/>
+          </a:prstGeom>
+          <a:noFill/>
+          <a:ln/>
+        </p:spPr>
+        <p:txBody>
+          <a:bodyPr wrap="square" lIns="0" tIns="0" rIns="0" bIns="0" rtlCol="0" anchor="ctr"/>
+          <a:lstStyle/>
+          <a:p>
+            <a:pPr marL="0" indent="0">
+              <a:buNone/>
+            </a:pPr>
+            <a:r>
+              <a:rPr lang="pl-PL" sz="3000" dirty="0">
+                <a:solidFill>
+                  <a:srgbClr val="000000"/>
+                </a:solidFill>
+                <a:latin typeface="Calibri" pitchFamily="34" charset="0"/>
+                <a:ea typeface="Calibri" pitchFamily="34" charset="-122"/>
+                <a:cs typeface="Calibri" pitchFamily="34" charset="-120"/>
+              </a:rPr>
+              <a:t>Porównanie próbek: High </a:t>
+            </a:r>
+            <a:r>
+              <a:rPr lang="pl-PL" sz="3000" dirty="0" err="1">
+                <a:solidFill>
+                  <a:srgbClr val="000000"/>
+                </a:solidFill>
+                <a:latin typeface="Calibri" pitchFamily="34" charset="0"/>
+                <a:ea typeface="Calibri" pitchFamily="34" charset="-122"/>
+                <a:cs typeface="Calibri" pitchFamily="34" charset="-120"/>
+              </a:rPr>
+              <a:t>VoG</a:t>
+            </a:r>
+            <a:r>
+              <a:rPr lang="pl-PL" sz="3000" dirty="0">
+                <a:solidFill>
+                  <a:srgbClr val="000000"/>
+                </a:solidFill>
+                <a:latin typeface="Calibri" pitchFamily="34" charset="0"/>
+                <a:ea typeface="Calibri" pitchFamily="34" charset="-122"/>
+                <a:cs typeface="Calibri" pitchFamily="34" charset="-120"/>
+              </a:rPr>
+              <a:t> vs </a:t>
+            </a:r>
+            <a:r>
+              <a:rPr lang="pl-PL" sz="3000" dirty="0" err="1">
+                <a:solidFill>
+                  <a:srgbClr val="000000"/>
+                </a:solidFill>
+                <a:latin typeface="Calibri" pitchFamily="34" charset="0"/>
+                <a:ea typeface="Calibri" pitchFamily="34" charset="-122"/>
+                <a:cs typeface="Calibri" pitchFamily="34" charset="-120"/>
+              </a:rPr>
+              <a:t>Low</a:t>
+            </a:r>
+            <a:r>
+              <a:rPr lang="pl-PL" sz="3000" dirty="0">
+                <a:solidFill>
+                  <a:srgbClr val="000000"/>
+                </a:solidFill>
+                <a:latin typeface="Calibri" pitchFamily="34" charset="0"/>
+                <a:ea typeface="Calibri" pitchFamily="34" charset="-122"/>
+                <a:cs typeface="Calibri" pitchFamily="34" charset="-120"/>
+              </a:rPr>
+              <a:t> </a:t>
+            </a:r>
+            <a:r>
+              <a:rPr lang="pl-PL" sz="3000" dirty="0" err="1">
+                <a:solidFill>
+                  <a:srgbClr val="000000"/>
+                </a:solidFill>
+                <a:latin typeface="Calibri" pitchFamily="34" charset="0"/>
+                <a:ea typeface="Calibri" pitchFamily="34" charset="-122"/>
+                <a:cs typeface="Calibri" pitchFamily="34" charset="-120"/>
+              </a:rPr>
+              <a:t>VoG</a:t>
+            </a:r>
+            <a:endParaRPr lang="en-US" sz="3000" dirty="0"/>
+          </a:p>
+        </p:txBody>
+      </p:sp>
+      <p:sp>
+        <p:nvSpPr>
+          <p:cNvPr id="9" name="Text 6">
+            <a:extLst>
+              <a:ext uri="{FF2B5EF4-FFF2-40B4-BE49-F238E27FC236}">
+                <a16:creationId xmlns:a16="http://schemas.microsoft.com/office/drawing/2014/main" id="{A10A102A-165C-D76A-1744-482E7549A335}"/>
+              </a:ext>
+            </a:extLst>
+          </p:cNvPr>
+          <p:cNvSpPr/>
+          <p:nvPr/>
+        </p:nvSpPr>
+        <p:spPr>
+          <a:xfrm>
+            <a:off x="11338560" y="6547104"/>
+            <a:ext cx="274320" cy="164592"/>
+          </a:xfrm>
+          <a:prstGeom prst="rect">
+            <a:avLst/>
+          </a:prstGeom>
+          <a:noFill/>
+          <a:ln/>
+        </p:spPr>
+        <p:txBody>
+          <a:bodyPr wrap="square" lIns="0" tIns="0" rIns="0" bIns="0" rtlCol="0" anchor="ctr"/>
+          <a:lstStyle/>
+          <a:p>
+            <a:pPr marL="0" indent="0" algn="r">
+              <a:buNone/>
+            </a:pPr>
+            <a:r>
+              <a:rPr lang="en-US" sz="780" dirty="0">
+                <a:solidFill>
+                  <a:srgbClr val="6B7280"/>
+                </a:solidFill>
+                <a:latin typeface="Calibri" pitchFamily="34" charset="0"/>
+                <a:ea typeface="Calibri" pitchFamily="34" charset="-122"/>
+                <a:cs typeface="Calibri" pitchFamily="34" charset="-120"/>
+              </a:rPr>
+              <a:t>6</a:t>
+            </a:r>
+            <a:endParaRPr lang="en-US" sz="780" dirty="0"/>
+          </a:p>
+        </p:txBody>
+      </p:sp>
       <p:pic>
         <p:nvPicPr>
-          <p:cNvPr id="3" name="Obraz 2">
+          <p:cNvPr id="4" name="Obraz 3">
             <a:extLst>
               <a:ext uri="{FF2B5EF4-FFF2-40B4-BE49-F238E27FC236}">
                 <a16:creationId xmlns:a16="http://schemas.microsoft.com/office/drawing/2014/main" id="{694B3155-DBAF-E4A5-CC6B-45C797E2EEAB}"/>
@@ -4718,15 +5591,15 @@
           <p:nvPr/>
         </p:nvPicPr>
         <p:blipFill>
-          <a:blip r:embed="rId2"/>
+          <a:blip r:embed="rId3"/>
           <a:stretch>
             <a:fillRect/>
           </a:stretch>
         </p:blipFill>
         <p:spPr>
           <a:xfrm>
-            <a:off x="1224232" y="0"/>
-            <a:ext cx="9743536" cy="6858000"/>
+            <a:off x="1985729" y="864815"/>
+            <a:ext cx="8190062" cy="5764585"/>
           </a:xfrm>
           <a:prstGeom prst="rect">
             <a:avLst/>
@@ -4736,7 +5609,7 @@
     </p:spTree>
     <p:extLst>
       <p:ext uri="{BB962C8B-B14F-4D97-AF65-F5344CB8AC3E}">
-        <p14:creationId xmlns:p14="http://schemas.microsoft.com/office/powerpoint/2010/main" val="1941323326"/>
+        <p14:creationId xmlns:p14="http://schemas.microsoft.com/office/powerpoint/2010/main" val="1925823591"/>
       </p:ext>
     </p:extLst>
   </p:cSld>
@@ -4826,7 +5699,7 @@
               <a:buNone/>
             </a:pPr>
             <a:r>
-              <a:rPr lang="en-US" sz="3000" dirty="0">
+              <a:rPr lang="pl-PL" sz="3000" dirty="0">
                 <a:solidFill>
                   <a:srgbClr val="000000"/>
                 </a:solidFill>
@@ -4834,45 +5707,67 @@
                 <a:ea typeface="Calibri" pitchFamily="34" charset="-122"/>
                 <a:cs typeface="Calibri" pitchFamily="34" charset="-120"/>
               </a:rPr>
-              <a:t>Hipotezy z artykułu vs nasze wyniki</a:t>
-            </a:r>
-            <a:endParaRPr lang="en-US" sz="3000" dirty="0"/>
-          </a:p>
-        </p:txBody>
-      </p:sp>
-      <p:sp>
-        <p:nvSpPr>
-          <p:cNvPr id="4" name="Text 2"/>
-          <p:cNvSpPr/>
-          <p:nvPr/>
-        </p:nvSpPr>
-        <p:spPr>
-          <a:xfrm>
-            <a:off x="603504" y="850392"/>
-            <a:ext cx="10698480" cy="329184"/>
-          </a:xfrm>
-          <a:prstGeom prst="rect">
-            <a:avLst/>
-          </a:prstGeom>
-          <a:noFill/>
-          <a:ln/>
-        </p:spPr>
-        <p:txBody>
-          <a:bodyPr wrap="square" lIns="0" tIns="0" rIns="0" bIns="0" rtlCol="0" anchor="ctr"/>
-          <a:lstStyle/>
-          <a:p>
-            <a:pPr marL="0" indent="0">
-              <a:buNone/>
-            </a:pPr>
-            <a:r>
-              <a:rPr lang="en-US" sz="1250" dirty="0">
-                <a:solidFill>
-                  <a:srgbClr val="6B7280"/>
+              <a:t>Podsumowanie: h</a:t>
+            </a:r>
+            <a:r>
+              <a:rPr lang="en-US" sz="3000" dirty="0" err="1">
+                <a:solidFill>
+                  <a:srgbClr val="000000"/>
                 </a:solidFill>
                 <a:latin typeface="Calibri" pitchFamily="34" charset="0"/>
                 <a:ea typeface="Calibri" pitchFamily="34" charset="-122"/>
                 <a:cs typeface="Calibri" pitchFamily="34" charset="-120"/>
               </a:rPr>
+              <a:t>ipotezy</a:t>
+            </a:r>
+            <a:r>
+              <a:rPr lang="en-US" sz="3000" dirty="0">
+                <a:solidFill>
+                  <a:srgbClr val="000000"/>
+                </a:solidFill>
+                <a:latin typeface="Calibri" pitchFamily="34" charset="0"/>
+                <a:ea typeface="Calibri" pitchFamily="34" charset="-122"/>
+                <a:cs typeface="Calibri" pitchFamily="34" charset="-120"/>
+              </a:rPr>
+              <a:t> z artykułu vs nasze wyniki</a:t>
+            </a:r>
+            <a:endParaRPr lang="en-US" sz="3000" dirty="0"/>
+          </a:p>
+        </p:txBody>
+      </p:sp>
+      <p:sp>
+        <p:nvSpPr>
+          <p:cNvPr id="4" name="Text 2"/>
+          <p:cNvSpPr/>
+          <p:nvPr/>
+        </p:nvSpPr>
+        <p:spPr>
+          <a:xfrm>
+            <a:off x="603504" y="850392"/>
+            <a:ext cx="10698480" cy="329184"/>
+          </a:xfrm>
+          <a:prstGeom prst="rect">
+            <a:avLst/>
+          </a:prstGeom>
+          <a:noFill/>
+          <a:ln/>
+        </p:spPr>
+        <p:txBody>
+          <a:bodyPr wrap="square" lIns="0" tIns="0" rIns="0" bIns="0" rtlCol="0" anchor="ctr"/>
+          <a:lstStyle/>
+          <a:p>
+            <a:pPr marL="0" indent="0">
+              <a:buNone/>
+            </a:pPr>
+            <a:r>
+              <a:rPr lang="en-US" sz="1250" dirty="0">
+                <a:solidFill>
+                  <a:srgbClr val="6B7280"/>
+                </a:solidFill>
+                <a:latin typeface="Calibri" pitchFamily="34" charset="0"/>
+                <a:ea typeface="Calibri" pitchFamily="34" charset="-122"/>
+                <a:cs typeface="Calibri" pitchFamily="34" charset="-120"/>
+              </a:rPr>
               <a:t>Czy wyniki z projektu potwierdzają zamysł VoG?</a:t>
             </a:r>
             <a:endParaRPr lang="en-US" sz="1250" dirty="0"/>
@@ -4887,7 +5782,7 @@
         </p:nvSpPr>
         <p:spPr>
           <a:xfrm>
-            <a:off x="822960" y="1234440"/>
+            <a:off x="868680" y="1990718"/>
             <a:ext cx="3657600" cy="274320"/>
           </a:xfrm>
           <a:prstGeom prst="rect">
@@ -4923,7 +5818,7 @@
         </p:nvSpPr>
         <p:spPr>
           <a:xfrm>
-            <a:off x="4663440" y="1234440"/>
+            <a:off x="4709160" y="1990718"/>
             <a:ext cx="1828800" cy="274320"/>
           </a:xfrm>
           <a:prstGeom prst="rect">
@@ -4959,7 +5854,7 @@
         </p:nvSpPr>
         <p:spPr>
           <a:xfrm>
-            <a:off x="6766560" y="1234440"/>
+            <a:off x="6812280" y="1990718"/>
             <a:ext cx="4389120" cy="274320"/>
           </a:xfrm>
           <a:prstGeom prst="rect">
@@ -4995,7 +5890,7 @@
         </p:nvSpPr>
         <p:spPr>
           <a:xfrm>
-            <a:off x="777240" y="1600200"/>
+            <a:off x="822960" y="2356478"/>
             <a:ext cx="3749040" cy="804672"/>
           </a:xfrm>
           <a:prstGeom prst="roundRect">
@@ -5029,7 +5924,7 @@
         </p:nvSpPr>
         <p:spPr>
           <a:xfrm>
-            <a:off x="932688" y="1719072"/>
+            <a:off x="978408" y="2475350"/>
             <a:ext cx="3429000" cy="512064"/>
           </a:xfrm>
           <a:prstGeom prst="rect">
@@ -5067,7 +5962,7 @@
         </p:nvSpPr>
         <p:spPr>
           <a:xfrm>
-            <a:off x="4709160" y="1600200"/>
+            <a:off x="4754880" y="2356478"/>
             <a:ext cx="1600200" cy="804672"/>
           </a:xfrm>
           <a:prstGeom prst="roundRect">
@@ -5101,7 +5996,7 @@
         </p:nvSpPr>
         <p:spPr>
           <a:xfrm>
-            <a:off x="4782312" y="1691640"/>
+            <a:off x="4828032" y="2447918"/>
             <a:ext cx="1453896" cy="228600"/>
           </a:xfrm>
           <a:prstGeom prst="rect">
@@ -5137,7 +6032,7 @@
         </p:nvSpPr>
         <p:spPr>
           <a:xfrm>
-            <a:off x="4855464" y="2039112"/>
+            <a:off x="4901184" y="2795390"/>
             <a:ext cx="1307592" cy="292608"/>
           </a:xfrm>
           <a:prstGeom prst="rect">
@@ -5167,7 +6062,7 @@
         </p:nvSpPr>
         <p:spPr>
           <a:xfrm>
-            <a:off x="6629400" y="1600200"/>
+            <a:off x="6675120" y="2356478"/>
             <a:ext cx="4663440" cy="804672"/>
           </a:xfrm>
           <a:prstGeom prst="roundRect">
@@ -5201,7 +6096,7 @@
         </p:nvSpPr>
         <p:spPr>
           <a:xfrm>
-            <a:off x="6784848" y="1700784"/>
+            <a:off x="6830568" y="2457062"/>
             <a:ext cx="4343400" cy="566928"/>
           </a:xfrm>
           <a:prstGeom prst="rect">
@@ -5239,7 +6134,7 @@
         </p:nvSpPr>
         <p:spPr>
           <a:xfrm>
-            <a:off x="777240" y="2606040"/>
+            <a:off x="822960" y="3362318"/>
             <a:ext cx="3749040" cy="804672"/>
           </a:xfrm>
           <a:prstGeom prst="roundRect">
@@ -5273,7 +6168,7 @@
         </p:nvSpPr>
         <p:spPr>
           <a:xfrm>
-            <a:off x="932688" y="2724912"/>
+            <a:off x="978408" y="3481190"/>
             <a:ext cx="3429000" cy="512064"/>
           </a:xfrm>
           <a:prstGeom prst="rect">
@@ -5311,7 +6206,7 @@
         </p:nvSpPr>
         <p:spPr>
           <a:xfrm>
-            <a:off x="4709160" y="2606040"/>
+            <a:off x="4754880" y="3362318"/>
             <a:ext cx="1600200" cy="804672"/>
           </a:xfrm>
           <a:prstGeom prst="roundRect">
@@ -5345,7 +6240,7 @@
         </p:nvSpPr>
         <p:spPr>
           <a:xfrm>
-            <a:off x="4782312" y="2697480"/>
+            <a:off x="4828032" y="3453758"/>
             <a:ext cx="1453896" cy="228600"/>
           </a:xfrm>
           <a:prstGeom prst="rect">
@@ -5381,7 +6276,7 @@
         </p:nvSpPr>
         <p:spPr>
           <a:xfrm>
-            <a:off x="4855464" y="3044952"/>
+            <a:off x="4901184" y="3801230"/>
             <a:ext cx="1307592" cy="292608"/>
           </a:xfrm>
           <a:prstGeom prst="rect">
@@ -5411,7 +6306,7 @@
         </p:nvSpPr>
         <p:spPr>
           <a:xfrm>
-            <a:off x="6629400" y="2606040"/>
+            <a:off x="6675120" y="3362318"/>
             <a:ext cx="4663440" cy="804672"/>
           </a:xfrm>
           <a:prstGeom prst="roundRect">
@@ -5445,7 +6340,7 @@
         </p:nvSpPr>
         <p:spPr>
           <a:xfrm>
-            <a:off x="6784848" y="2706624"/>
+            <a:off x="6830568" y="3462902"/>
             <a:ext cx="4343400" cy="566928"/>
           </a:xfrm>
           <a:prstGeom prst="rect">
@@ -5483,7 +6378,7 @@
         </p:nvSpPr>
         <p:spPr>
           <a:xfrm>
-            <a:off x="777240" y="3611880"/>
+            <a:off x="822960" y="4368158"/>
             <a:ext cx="3749040" cy="804672"/>
           </a:xfrm>
           <a:prstGeom prst="roundRect">
@@ -5517,7 +6412,7 @@
         </p:nvSpPr>
         <p:spPr>
           <a:xfrm>
-            <a:off x="932688" y="3730752"/>
+            <a:off x="978408" y="4487030"/>
             <a:ext cx="3429000" cy="512064"/>
           </a:xfrm>
           <a:prstGeom prst="rect">
@@ -5555,7 +6450,7 @@
         </p:nvSpPr>
         <p:spPr>
           <a:xfrm>
-            <a:off x="4709160" y="3611880"/>
+            <a:off x="4754880" y="4368158"/>
             <a:ext cx="1600200" cy="804672"/>
           </a:xfrm>
           <a:prstGeom prst="roundRect">
@@ -5589,7 +6484,7 @@
         </p:nvSpPr>
         <p:spPr>
           <a:xfrm>
-            <a:off x="4782312" y="3703320"/>
+            <a:off x="4828032" y="4459598"/>
             <a:ext cx="1453896" cy="228600"/>
           </a:xfrm>
           <a:prstGeom prst="rect">
@@ -5625,7 +6520,7 @@
         </p:nvSpPr>
         <p:spPr>
           <a:xfrm>
-            <a:off x="4855464" y="4050792"/>
+            <a:off x="4901184" y="4807070"/>
             <a:ext cx="1307592" cy="292608"/>
           </a:xfrm>
           <a:prstGeom prst="rect">
@@ -5655,7 +6550,7 @@
         </p:nvSpPr>
         <p:spPr>
           <a:xfrm>
-            <a:off x="6629400" y="3611880"/>
+            <a:off x="6675120" y="4368158"/>
             <a:ext cx="4663440" cy="804672"/>
           </a:xfrm>
           <a:prstGeom prst="roundRect">
@@ -5689,7 +6584,7 @@
         </p:nvSpPr>
         <p:spPr>
           <a:xfrm>
-            <a:off x="6784848" y="3712464"/>
+            <a:off x="6830568" y="4468742"/>
             <a:ext cx="4343400" cy="566928"/>
           </a:xfrm>
           <a:prstGeom prst="rect">
@@ -5721,48 +6616,14 @@
       </p:sp>
       <p:sp>
         <p:nvSpPr>
-          <p:cNvPr id="29" name="Shape 27"/>
-          <p:cNvSpPr/>
-          <p:nvPr/>
-        </p:nvSpPr>
-        <p:spPr>
-          <a:xfrm>
-            <a:off x="777240" y="4617720"/>
-            <a:ext cx="3749040" cy="804672"/>
-          </a:xfrm>
-          <a:prstGeom prst="roundRect">
-            <a:avLst>
-              <a:gd name="adj" fmla="val 7955"/>
-            </a:avLst>
-          </a:prstGeom>
-          <a:solidFill>
-            <a:srgbClr val="FFFFFF"/>
-          </a:solidFill>
-          <a:ln w="8890">
-            <a:solidFill>
-              <a:srgbClr val="D1D5DB"/>
-            </a:solidFill>
-            <a:prstDash val="solid"/>
-          </a:ln>
-        </p:spPr>
-        <p:txBody>
-          <a:bodyPr/>
-          <a:lstStyle/>
-          <a:p>
-            <a:endParaRPr lang="pl-PL"/>
-          </a:p>
-        </p:txBody>
-      </p:sp>
-      <p:sp>
-        <p:nvSpPr>
-          <p:cNvPr id="30" name="Text 28"/>
-          <p:cNvSpPr/>
-          <p:nvPr/>
-        </p:nvSpPr>
-        <p:spPr>
-          <a:xfrm>
-            <a:off x="932688" y="4736592"/>
-            <a:ext cx="3429000" cy="512064"/>
+          <p:cNvPr id="33" name="Text 31"/>
+          <p:cNvSpPr/>
+          <p:nvPr/>
+        </p:nvSpPr>
+        <p:spPr>
+          <a:xfrm>
+            <a:off x="4855464" y="5056632"/>
+            <a:ext cx="1307592" cy="292608"/>
           </a:xfrm>
           <a:prstGeom prst="rect">
             <a:avLst/>
@@ -5779,62 +6640,20 @@
             <a:pPr marL="0" indent="0">
               <a:buNone/>
             </a:pPr>
-            <a:r>
-              <a:rPr lang="en-US" sz="1140" dirty="0">
-                <a:solidFill>
-                  <a:srgbClr val="111827"/>
-                </a:solidFill>
-              </a:rPr>
-              <a:t>VoG nadaje się do OoD / memorization audit</a:t>
-            </a:r>
-            <a:endParaRPr lang="en-US" sz="1140" dirty="0"/>
-          </a:p>
-        </p:txBody>
-      </p:sp>
-      <p:sp>
-        <p:nvSpPr>
-          <p:cNvPr id="31" name="Shape 29"/>
-          <p:cNvSpPr/>
-          <p:nvPr/>
-        </p:nvSpPr>
-        <p:spPr>
-          <a:xfrm>
-            <a:off x="4709160" y="4617720"/>
-            <a:ext cx="1600200" cy="804672"/>
-          </a:xfrm>
-          <a:prstGeom prst="roundRect">
-            <a:avLst>
-              <a:gd name="adj" fmla="val 9091"/>
-            </a:avLst>
-          </a:prstGeom>
-          <a:solidFill>
-            <a:srgbClr val="FFFFFF"/>
-          </a:solidFill>
-          <a:ln w="15240">
-            <a:solidFill>
-              <a:srgbClr val="6B7280"/>
-            </a:solidFill>
-            <a:prstDash val="solid"/>
-          </a:ln>
-        </p:spPr>
-        <p:txBody>
-          <a:bodyPr/>
-          <a:lstStyle/>
-          <a:p>
-            <a:endParaRPr lang="pl-PL"/>
-          </a:p>
-        </p:txBody>
-      </p:sp>
-      <p:sp>
-        <p:nvSpPr>
-          <p:cNvPr id="32" name="Text 30"/>
-          <p:cNvSpPr/>
-          <p:nvPr/>
-        </p:nvSpPr>
-        <p:spPr>
-          <a:xfrm>
-            <a:off x="4782312" y="4709160"/>
-            <a:ext cx="1453896" cy="228600"/>
+            <a:endParaRPr lang="en-US" sz="940" dirty="0"/>
+          </a:p>
+        </p:txBody>
+      </p:sp>
+      <p:sp>
+        <p:nvSpPr>
+          <p:cNvPr id="38" name="Text 36"/>
+          <p:cNvSpPr/>
+          <p:nvPr/>
+        </p:nvSpPr>
+        <p:spPr>
+          <a:xfrm>
+            <a:off x="11338560" y="6547104"/>
+            <a:ext cx="274320" cy="164592"/>
           </a:xfrm>
           <a:prstGeom prst="rect">
             <a:avLst/>
@@ -5846,181 +6665,7 @@
           <a:bodyPr wrap="square" lIns="0" tIns="0" rIns="0" bIns="0" rtlCol="0" anchor="ctr"/>
           <a:lstStyle/>
           <a:p>
-            <a:pPr marL="0" indent="0" algn="ctr">
-              <a:buNone/>
-            </a:pPr>
-            <a:r>
-              <a:rPr lang="en-US" sz="1300" b="1" dirty="0">
-                <a:solidFill>
-                  <a:srgbClr val="6B7280"/>
-                </a:solidFill>
-              </a:rPr>
-              <a:t>NIE TESTOWANO</a:t>
-            </a:r>
-            <a:endParaRPr lang="en-US" sz="1300" dirty="0"/>
-          </a:p>
-        </p:txBody>
-      </p:sp>
-      <p:sp>
-        <p:nvSpPr>
-          <p:cNvPr id="33" name="Text 31"/>
-          <p:cNvSpPr/>
-          <p:nvPr/>
-        </p:nvSpPr>
-        <p:spPr>
-          <a:xfrm>
-            <a:off x="4855464" y="5056632"/>
-            <a:ext cx="1307592" cy="292608"/>
-          </a:xfrm>
-          <a:prstGeom prst="rect">
-            <a:avLst/>
-          </a:prstGeom>
-          <a:noFill/>
-          <a:ln/>
-        </p:spPr>
-        <p:txBody>
-          <a:bodyPr wrap="square" lIns="127" tIns="127" rIns="127" bIns="127" rtlCol="0" anchor="ctr">
-            <a:normAutofit/>
-          </a:bodyPr>
-          <a:lstStyle/>
-          <a:p>
-            <a:pPr marL="0" indent="0">
-              <a:buNone/>
-            </a:pPr>
-            <a:endParaRPr lang="en-US" sz="940" dirty="0"/>
-          </a:p>
-        </p:txBody>
-      </p:sp>
-      <p:sp>
-        <p:nvSpPr>
-          <p:cNvPr id="34" name="Shape 32"/>
-          <p:cNvSpPr/>
-          <p:nvPr/>
-        </p:nvSpPr>
-        <p:spPr>
-          <a:xfrm>
-            <a:off x="6629400" y="4617720"/>
-            <a:ext cx="4663440" cy="804672"/>
-          </a:xfrm>
-          <a:prstGeom prst="roundRect">
-            <a:avLst>
-              <a:gd name="adj" fmla="val 7955"/>
-            </a:avLst>
-          </a:prstGeom>
-          <a:solidFill>
-            <a:srgbClr val="FFFFFF"/>
-          </a:solidFill>
-          <a:ln w="8890">
-            <a:solidFill>
-              <a:srgbClr val="D1D5DB"/>
-            </a:solidFill>
-            <a:prstDash val="solid"/>
-          </a:ln>
-        </p:spPr>
-        <p:txBody>
-          <a:bodyPr/>
-          <a:lstStyle/>
-          <a:p>
-            <a:endParaRPr lang="pl-PL"/>
-          </a:p>
-        </p:txBody>
-      </p:sp>
-      <p:sp>
-        <p:nvSpPr>
-          <p:cNvPr id="35" name="Text 33"/>
-          <p:cNvSpPr/>
-          <p:nvPr/>
-        </p:nvSpPr>
-        <p:spPr>
-          <a:xfrm>
-            <a:off x="6784848" y="4718304"/>
-            <a:ext cx="4343400" cy="566928"/>
-          </a:xfrm>
-          <a:prstGeom prst="rect">
-            <a:avLst/>
-          </a:prstGeom>
-          <a:noFill/>
-          <a:ln/>
-        </p:spPr>
-        <p:txBody>
-          <a:bodyPr wrap="square" lIns="127" tIns="127" rIns="127" bIns="127" rtlCol="0" anchor="ctr">
-            <a:normAutofit/>
-          </a:bodyPr>
-          <a:lstStyle/>
-          <a:p>
-            <a:pPr marL="0" indent="0">
-              <a:buNone/>
-            </a:pPr>
-            <a:r>
-              <a:rPr lang="en-US" sz="1080" dirty="0">
-                <a:solidFill>
-                  <a:srgbClr val="111827"/>
-                </a:solidFill>
-              </a:rPr>
-              <a:t>Artykuł pokazuje ten kierunek, ale nasz zakres obejmował dobór podzbiorów i transfer architektury.</a:t>
-            </a:r>
-            <a:endParaRPr lang="en-US" sz="1080" dirty="0"/>
-          </a:p>
-        </p:txBody>
-      </p:sp>
-      <p:sp>
-        <p:nvSpPr>
-          <p:cNvPr id="36" name="Text 34"/>
-          <p:cNvSpPr/>
-          <p:nvPr/>
-        </p:nvSpPr>
-        <p:spPr>
-          <a:xfrm>
-            <a:off x="914400" y="5806440"/>
-            <a:ext cx="10332720" cy="347472"/>
-          </a:xfrm>
-          <a:prstGeom prst="rect">
-            <a:avLst/>
-          </a:prstGeom>
-          <a:noFill/>
-          <a:ln/>
-        </p:spPr>
-        <p:txBody>
-          <a:bodyPr wrap="square" lIns="0" tIns="0" rIns="0" bIns="0" rtlCol="0" anchor="ctr"/>
-          <a:lstStyle/>
-          <a:p>
-            <a:pPr marL="0" indent="0" algn="ctr">
-              <a:buNone/>
-            </a:pPr>
-            <a:r>
-              <a:rPr lang="en-US" sz="1350" dirty="0">
-                <a:solidFill>
-                  <a:srgbClr val="111827"/>
-                </a:solidFill>
-              </a:rPr>
-              <a:t>Konkluzja: projekt wspiera główną intuicję VoG, ale nie potwierdza pełnej uniwersalności bez zastrzeżeń.</a:t>
-            </a:r>
-            <a:endParaRPr lang="en-US" sz="1350" dirty="0"/>
-          </a:p>
-        </p:txBody>
-      </p:sp>
-      <p:sp>
-        <p:nvSpPr>
-          <p:cNvPr id="37" name="Text 35"/>
-          <p:cNvSpPr/>
-          <p:nvPr/>
-        </p:nvSpPr>
-        <p:spPr>
-          <a:xfrm>
-            <a:off x="594360" y="6547104"/>
-            <a:ext cx="9601200" cy="164592"/>
-          </a:xfrm>
-          <a:prstGeom prst="rect">
-            <a:avLst/>
-          </a:prstGeom>
-          <a:noFill/>
-          <a:ln/>
-        </p:spPr>
-        <p:txBody>
-          <a:bodyPr wrap="square" lIns="0" tIns="0" rIns="0" bIns="0" rtlCol="0" anchor="ctr"/>
-          <a:lstStyle/>
-          <a:p>
-            <a:pPr marL="0" indent="0">
+            <a:pPr marL="0" indent="0" algn="r">
               <a:buNone/>
             </a:pPr>
             <a:r>
@@ -6032,1736 +6677,7 @@
                 <a:ea typeface="Calibri" pitchFamily="34" charset="-122"/>
                 <a:cs typeface="Calibri" pitchFamily="34" charset="-120"/>
               </a:rPr>
-              <a:t>Macierz dowodów: artykuł vs wyniki Phase 2/Phase 3</a:t>
-            </a:r>
-            <a:endParaRPr lang="en-US" sz="780" dirty="0"/>
-          </a:p>
-        </p:txBody>
-      </p:sp>
-      <p:sp>
-        <p:nvSpPr>
-          <p:cNvPr id="38" name="Text 36"/>
-          <p:cNvSpPr/>
-          <p:nvPr/>
-        </p:nvSpPr>
-        <p:spPr>
-          <a:xfrm>
-            <a:off x="11338560" y="6547104"/>
-            <a:ext cx="274320" cy="164592"/>
-          </a:xfrm>
-          <a:prstGeom prst="rect">
-            <a:avLst/>
-          </a:prstGeom>
-          <a:noFill/>
-          <a:ln/>
-        </p:spPr>
-        <p:txBody>
-          <a:bodyPr wrap="square" lIns="0" tIns="0" rIns="0" bIns="0" rtlCol="0" anchor="ctr"/>
-          <a:lstStyle/>
-          <a:p>
-            <a:pPr marL="0" indent="0" algn="r">
-              <a:buNone/>
-            </a:pPr>
-            <a:r>
-              <a:rPr lang="en-US" sz="780" dirty="0">
-                <a:solidFill>
-                  <a:srgbClr val="6B7280"/>
-                </a:solidFill>
-                <a:latin typeface="Calibri" pitchFamily="34" charset="0"/>
-                <a:ea typeface="Calibri" pitchFamily="34" charset="-122"/>
-                <a:cs typeface="Calibri" pitchFamily="34" charset="-120"/>
-              </a:rPr>
               <a:t>14</a:t>
-            </a:r>
-            <a:endParaRPr lang="en-US" sz="780" dirty="0"/>
-          </a:p>
-        </p:txBody>
-      </p:sp>
-    </p:spTree>
-  </p:cSld>
-  <p:clrMapOvr>
-    <a:masterClrMapping/>
-  </p:clrMapOvr>
-</p:sld>
-</file>
-
-<file path=ppt/slides/slide17.xml><?xml version="1.0" encoding="utf-8"?>
-<p:sld xmlns:a="http://schemas.openxmlformats.org/drawingml/2006/main" xmlns:r="http://schemas.openxmlformats.org/officeDocument/2006/relationships" xmlns:p="http://schemas.openxmlformats.org/presentationml/2006/main">
-  <p:cSld name="Slide 15">
-    <p:bg>
-      <p:bgPr>
-        <a:solidFill>
-          <a:srgbClr val="FFFFFF"/>
-        </a:solidFill>
-        <a:effectLst/>
-      </p:bgPr>
-    </p:bg>
-    <p:spTree>
-      <p:nvGrpSpPr>
-        <p:cNvPr id="1" name=""/>
-        <p:cNvGrpSpPr/>
-        <p:nvPr/>
-      </p:nvGrpSpPr>
-      <p:grpSpPr>
-        <a:xfrm>
-          <a:off x="0" y="0"/>
-          <a:ext cx="0" cy="0"/>
-          <a:chOff x="0" y="0"/>
-          <a:chExt cx="0" cy="0"/>
-        </a:xfrm>
-      </p:grpSpPr>
-      <p:sp>
-        <p:nvSpPr>
-          <p:cNvPr id="2" name="Shape 0"/>
-          <p:cNvSpPr/>
-          <p:nvPr/>
-        </p:nvSpPr>
-        <p:spPr>
-          <a:xfrm>
-            <a:off x="594360" y="6473952"/>
-            <a:ext cx="10972800" cy="0"/>
-          </a:xfrm>
-          <a:prstGeom prst="line">
-            <a:avLst/>
-          </a:prstGeom>
-          <a:noFill/>
-          <a:ln w="6350">
-            <a:solidFill>
-              <a:srgbClr val="D1D5DB"/>
-            </a:solidFill>
-            <a:prstDash val="solid"/>
-          </a:ln>
-        </p:spPr>
-        <p:txBody>
-          <a:bodyPr/>
-          <a:lstStyle/>
-          <a:p>
-            <a:endParaRPr lang="pl-PL"/>
-          </a:p>
-        </p:txBody>
-      </p:sp>
-      <p:sp>
-        <p:nvSpPr>
-          <p:cNvPr id="3" name="Text 1"/>
-          <p:cNvSpPr/>
-          <p:nvPr/>
-        </p:nvSpPr>
-        <p:spPr>
-          <a:xfrm>
-            <a:off x="594360" y="292608"/>
-            <a:ext cx="10972800" cy="502920"/>
-          </a:xfrm>
-          <a:prstGeom prst="rect">
-            <a:avLst/>
-          </a:prstGeom>
-          <a:noFill/>
-          <a:ln/>
-        </p:spPr>
-        <p:txBody>
-          <a:bodyPr wrap="square" lIns="0" tIns="0" rIns="0" bIns="0" rtlCol="0" anchor="ctr"/>
-          <a:lstStyle/>
-          <a:p>
-            <a:pPr marL="0" indent="0">
-              <a:buNone/>
-            </a:pPr>
-            <a:r>
-              <a:rPr lang="en-US" sz="3000" dirty="0">
-                <a:solidFill>
-                  <a:srgbClr val="000000"/>
-                </a:solidFill>
-                <a:latin typeface="Calibri" pitchFamily="34" charset="0"/>
-                <a:ea typeface="Calibri" pitchFamily="34" charset="-122"/>
-                <a:cs typeface="Calibri" pitchFamily="34" charset="-120"/>
-              </a:rPr>
-              <a:t>Ograniczenia eksperymentów</a:t>
-            </a:r>
-            <a:endParaRPr lang="en-US" sz="3000" dirty="0"/>
-          </a:p>
-        </p:txBody>
-      </p:sp>
-      <p:sp>
-        <p:nvSpPr>
-          <p:cNvPr id="4" name="Text 2"/>
-          <p:cNvSpPr/>
-          <p:nvPr/>
-        </p:nvSpPr>
-        <p:spPr>
-          <a:xfrm>
-            <a:off x="603504" y="850392"/>
-            <a:ext cx="10698480" cy="329184"/>
-          </a:xfrm>
-          <a:prstGeom prst="rect">
-            <a:avLst/>
-          </a:prstGeom>
-          <a:noFill/>
-          <a:ln/>
-        </p:spPr>
-        <p:txBody>
-          <a:bodyPr wrap="square" lIns="0" tIns="0" rIns="0" bIns="0" rtlCol="0" anchor="ctr"/>
-          <a:lstStyle/>
-          <a:p>
-            <a:pPr marL="0" indent="0">
-              <a:buNone/>
-            </a:pPr>
-            <a:r>
-              <a:rPr lang="en-US" sz="1250" dirty="0">
-                <a:solidFill>
-                  <a:srgbClr val="6B7280"/>
-                </a:solidFill>
-                <a:latin typeface="Calibri" pitchFamily="34" charset="0"/>
-                <a:ea typeface="Calibri" pitchFamily="34" charset="-122"/>
-                <a:cs typeface="Calibri" pitchFamily="34" charset="-120"/>
-              </a:rPr>
-              <a:t>Uczciwa interpretacja: wyniki są obiecujące, ale nie zamykają tematu.</a:t>
-            </a:r>
-            <a:endParaRPr lang="en-US" sz="1250" dirty="0"/>
-          </a:p>
-        </p:txBody>
-      </p:sp>
-      <p:sp>
-        <p:nvSpPr>
-          <p:cNvPr id="5" name="Shape 3"/>
-          <p:cNvSpPr/>
-          <p:nvPr/>
-        </p:nvSpPr>
-        <p:spPr>
-          <a:xfrm>
-            <a:off x="731520" y="1325880"/>
-            <a:ext cx="2651760" cy="1920240"/>
-          </a:xfrm>
-          <a:prstGeom prst="roundRect">
-            <a:avLst>
-              <a:gd name="adj" fmla="val 4762"/>
-            </a:avLst>
-          </a:prstGeom>
-          <a:solidFill>
-            <a:srgbClr val="FFFFFF"/>
-          </a:solidFill>
-          <a:ln w="12700">
-            <a:solidFill>
-              <a:srgbClr val="D1D5DB"/>
-            </a:solidFill>
-            <a:prstDash val="solid"/>
-          </a:ln>
-        </p:spPr>
-        <p:txBody>
-          <a:bodyPr/>
-          <a:lstStyle/>
-          <a:p>
-            <a:endParaRPr lang="pl-PL"/>
-          </a:p>
-        </p:txBody>
-      </p:sp>
-      <p:sp>
-        <p:nvSpPr>
-          <p:cNvPr id="6" name="Shape 4"/>
-          <p:cNvSpPr/>
-          <p:nvPr/>
-        </p:nvSpPr>
-        <p:spPr>
-          <a:xfrm>
-            <a:off x="896112" y="1828800"/>
-            <a:ext cx="2322576" cy="0"/>
-          </a:xfrm>
-          <a:prstGeom prst="line">
-            <a:avLst/>
-          </a:prstGeom>
-          <a:noFill/>
-          <a:ln w="25400">
-            <a:solidFill>
-              <a:srgbClr val="F59E0B"/>
-            </a:solidFill>
-            <a:prstDash val="solid"/>
-          </a:ln>
-        </p:spPr>
-        <p:txBody>
-          <a:bodyPr/>
-          <a:lstStyle/>
-          <a:p>
-            <a:endParaRPr lang="pl-PL"/>
-          </a:p>
-        </p:txBody>
-      </p:sp>
-      <p:sp>
-        <p:nvSpPr>
-          <p:cNvPr id="7" name="Text 5"/>
-          <p:cNvSpPr/>
-          <p:nvPr/>
-        </p:nvSpPr>
-        <p:spPr>
-          <a:xfrm>
-            <a:off x="896112" y="1472184"/>
-            <a:ext cx="2322576" cy="320040"/>
-          </a:xfrm>
-          <a:prstGeom prst="rect">
-            <a:avLst/>
-          </a:prstGeom>
-          <a:noFill/>
-          <a:ln/>
-        </p:spPr>
-        <p:txBody>
-          <a:bodyPr wrap="square" lIns="0" tIns="0" rIns="0" bIns="0" rtlCol="0" anchor="ctr"/>
-          <a:lstStyle/>
-          <a:p>
-            <a:pPr marL="0" indent="0">
-              <a:buNone/>
-            </a:pPr>
-            <a:r>
-              <a:rPr lang="en-US" sz="1500" b="1" dirty="0">
-                <a:solidFill>
-                  <a:srgbClr val="F59E0B"/>
-                </a:solidFill>
-              </a:rPr>
-              <a:t>Metryka</a:t>
-            </a:r>
-            <a:endParaRPr lang="en-US" sz="1500" dirty="0"/>
-          </a:p>
-        </p:txBody>
-      </p:sp>
-      <p:sp>
-        <p:nvSpPr>
-          <p:cNvPr id="8" name="Text 6"/>
-          <p:cNvSpPr/>
-          <p:nvPr/>
-        </p:nvSpPr>
-        <p:spPr>
-          <a:xfrm>
-            <a:off x="896112" y="2039112"/>
-            <a:ext cx="2322576" cy="1097280"/>
-          </a:xfrm>
-          <a:prstGeom prst="rect">
-            <a:avLst/>
-          </a:prstGeom>
-          <a:noFill/>
-          <a:ln/>
-        </p:spPr>
-        <p:txBody>
-          <a:bodyPr wrap="square" lIns="254" tIns="254" rIns="254" bIns="254" rtlCol="0" anchor="ctr">
-            <a:normAutofit/>
-          </a:bodyPr>
-          <a:lstStyle/>
-          <a:p>
-            <a:pPr marL="0" indent="0">
-              <a:buNone/>
-            </a:pPr>
-            <a:r>
-              <a:rPr lang="en-US" sz="1400" dirty="0">
-                <a:solidFill>
-                  <a:srgbClr val="111827"/>
-                </a:solidFill>
-              </a:rPr>
-              <a:t>Notebooki używają surowego, uśrednionego std gradientu; pełna normalizacja klasowa z paperu nie została konsekwentnie odtworzona.</a:t>
-            </a:r>
-            <a:endParaRPr lang="en-US" sz="1400" dirty="0"/>
-          </a:p>
-        </p:txBody>
-      </p:sp>
-      <p:sp>
-        <p:nvSpPr>
-          <p:cNvPr id="9" name="Shape 7"/>
-          <p:cNvSpPr/>
-          <p:nvPr/>
-        </p:nvSpPr>
-        <p:spPr>
-          <a:xfrm>
-            <a:off x="3611880" y="1325880"/>
-            <a:ext cx="2651760" cy="1920240"/>
-          </a:xfrm>
-          <a:prstGeom prst="roundRect">
-            <a:avLst>
-              <a:gd name="adj" fmla="val 4762"/>
-            </a:avLst>
-          </a:prstGeom>
-          <a:solidFill>
-            <a:srgbClr val="FFFFFF"/>
-          </a:solidFill>
-          <a:ln w="12700">
-            <a:solidFill>
-              <a:srgbClr val="D1D5DB"/>
-            </a:solidFill>
-            <a:prstDash val="solid"/>
-          </a:ln>
-        </p:spPr>
-        <p:txBody>
-          <a:bodyPr/>
-          <a:lstStyle/>
-          <a:p>
-            <a:endParaRPr lang="pl-PL"/>
-          </a:p>
-        </p:txBody>
-      </p:sp>
-      <p:sp>
-        <p:nvSpPr>
-          <p:cNvPr id="10" name="Shape 8"/>
-          <p:cNvSpPr/>
-          <p:nvPr/>
-        </p:nvSpPr>
-        <p:spPr>
-          <a:xfrm>
-            <a:off x="3776472" y="1828800"/>
-            <a:ext cx="2322576" cy="0"/>
-          </a:xfrm>
-          <a:prstGeom prst="line">
-            <a:avLst/>
-          </a:prstGeom>
-          <a:noFill/>
-          <a:ln w="25400">
-            <a:solidFill>
-              <a:srgbClr val="3B82F6"/>
-            </a:solidFill>
-            <a:prstDash val="solid"/>
-          </a:ln>
-        </p:spPr>
-        <p:txBody>
-          <a:bodyPr/>
-          <a:lstStyle/>
-          <a:p>
-            <a:endParaRPr lang="pl-PL"/>
-          </a:p>
-        </p:txBody>
-      </p:sp>
-      <p:sp>
-        <p:nvSpPr>
-          <p:cNvPr id="11" name="Text 9"/>
-          <p:cNvSpPr/>
-          <p:nvPr/>
-        </p:nvSpPr>
-        <p:spPr>
-          <a:xfrm>
-            <a:off x="3776472" y="1472184"/>
-            <a:ext cx="2322576" cy="320040"/>
-          </a:xfrm>
-          <a:prstGeom prst="rect">
-            <a:avLst/>
-          </a:prstGeom>
-          <a:noFill/>
-          <a:ln/>
-        </p:spPr>
-        <p:txBody>
-          <a:bodyPr wrap="square" lIns="0" tIns="0" rIns="0" bIns="0" rtlCol="0" anchor="ctr"/>
-          <a:lstStyle/>
-          <a:p>
-            <a:pPr marL="0" indent="0">
-              <a:buNone/>
-            </a:pPr>
-            <a:r>
-              <a:rPr lang="en-US" sz="1500" b="1" dirty="0">
-                <a:solidFill>
-                  <a:srgbClr val="3B82F6"/>
-                </a:solidFill>
-              </a:rPr>
-              <a:t>Dataset</a:t>
-            </a:r>
-            <a:endParaRPr lang="en-US" sz="1500" dirty="0"/>
-          </a:p>
-        </p:txBody>
-      </p:sp>
-      <p:sp>
-        <p:nvSpPr>
-          <p:cNvPr id="12" name="Text 10"/>
-          <p:cNvSpPr/>
-          <p:nvPr/>
-        </p:nvSpPr>
-        <p:spPr>
-          <a:xfrm>
-            <a:off x="3776472" y="2039112"/>
-            <a:ext cx="2322576" cy="1097280"/>
-          </a:xfrm>
-          <a:prstGeom prst="rect">
-            <a:avLst/>
-          </a:prstGeom>
-          <a:noFill/>
-          <a:ln/>
-        </p:spPr>
-        <p:txBody>
-          <a:bodyPr wrap="square" lIns="254" tIns="254" rIns="254" bIns="254" rtlCol="0" anchor="ctr">
-            <a:normAutofit/>
-          </a:bodyPr>
-          <a:lstStyle/>
-          <a:p>
-            <a:pPr marL="0" indent="0">
-              <a:buNone/>
-            </a:pPr>
-            <a:r>
-              <a:rPr lang="en-US" sz="1400" dirty="0">
-                <a:solidFill>
-                  <a:srgbClr val="111827"/>
-                </a:solidFill>
-              </a:rPr>
-              <a:t>Jeden zbiór: Imagenette. Brak testów na CIFAR/ImageNet oraz brak dedykowanego benchmarku OoD.</a:t>
-            </a:r>
-            <a:endParaRPr lang="en-US" sz="1400" dirty="0"/>
-          </a:p>
-        </p:txBody>
-      </p:sp>
-      <p:sp>
-        <p:nvSpPr>
-          <p:cNvPr id="13" name="Shape 11"/>
-          <p:cNvSpPr/>
-          <p:nvPr/>
-        </p:nvSpPr>
-        <p:spPr>
-          <a:xfrm>
-            <a:off x="6492240" y="1325880"/>
-            <a:ext cx="2651760" cy="1920240"/>
-          </a:xfrm>
-          <a:prstGeom prst="roundRect">
-            <a:avLst>
-              <a:gd name="adj" fmla="val 4762"/>
-            </a:avLst>
-          </a:prstGeom>
-          <a:solidFill>
-            <a:srgbClr val="FFFFFF"/>
-          </a:solidFill>
-          <a:ln w="12700">
-            <a:solidFill>
-              <a:srgbClr val="D1D5DB"/>
-            </a:solidFill>
-            <a:prstDash val="solid"/>
-          </a:ln>
-        </p:spPr>
-        <p:txBody>
-          <a:bodyPr/>
-          <a:lstStyle/>
-          <a:p>
-            <a:endParaRPr lang="pl-PL"/>
-          </a:p>
-        </p:txBody>
-      </p:sp>
-      <p:sp>
-        <p:nvSpPr>
-          <p:cNvPr id="14" name="Shape 12"/>
-          <p:cNvSpPr/>
-          <p:nvPr/>
-        </p:nvSpPr>
-        <p:spPr>
-          <a:xfrm>
-            <a:off x="6656832" y="1828800"/>
-            <a:ext cx="2322576" cy="0"/>
-          </a:xfrm>
-          <a:prstGeom prst="line">
-            <a:avLst/>
-          </a:prstGeom>
-          <a:noFill/>
-          <a:ln w="25400">
-            <a:solidFill>
-              <a:srgbClr val="8B5CF6"/>
-            </a:solidFill>
-            <a:prstDash val="solid"/>
-          </a:ln>
-        </p:spPr>
-        <p:txBody>
-          <a:bodyPr/>
-          <a:lstStyle/>
-          <a:p>
-            <a:endParaRPr lang="pl-PL"/>
-          </a:p>
-        </p:txBody>
-      </p:sp>
-      <p:sp>
-        <p:nvSpPr>
-          <p:cNvPr id="15" name="Text 13"/>
-          <p:cNvSpPr/>
-          <p:nvPr/>
-        </p:nvSpPr>
-        <p:spPr>
-          <a:xfrm>
-            <a:off x="6656832" y="1472184"/>
-            <a:ext cx="2322576" cy="320040"/>
-          </a:xfrm>
-          <a:prstGeom prst="rect">
-            <a:avLst/>
-          </a:prstGeom>
-          <a:noFill/>
-          <a:ln/>
-        </p:spPr>
-        <p:txBody>
-          <a:bodyPr wrap="square" lIns="0" tIns="0" rIns="0" bIns="0" rtlCol="0" anchor="ctr"/>
-          <a:lstStyle/>
-          <a:p>
-            <a:pPr marL="0" indent="0">
-              <a:buNone/>
-            </a:pPr>
-            <a:r>
-              <a:rPr lang="en-US" sz="1500" b="1" dirty="0">
-                <a:solidFill>
-                  <a:srgbClr val="8B5CF6"/>
-                </a:solidFill>
-              </a:rPr>
-              <a:t>Compute</a:t>
-            </a:r>
-            <a:endParaRPr lang="en-US" sz="1500" dirty="0"/>
-          </a:p>
-        </p:txBody>
-      </p:sp>
-      <p:sp>
-        <p:nvSpPr>
-          <p:cNvPr id="16" name="Text 14"/>
-          <p:cNvSpPr/>
-          <p:nvPr/>
-        </p:nvSpPr>
-        <p:spPr>
-          <a:xfrm>
-            <a:off x="6656832" y="2039112"/>
-            <a:ext cx="2322576" cy="1097280"/>
-          </a:xfrm>
-          <a:prstGeom prst="rect">
-            <a:avLst/>
-          </a:prstGeom>
-          <a:noFill/>
-          <a:ln/>
-        </p:spPr>
-        <p:txBody>
-          <a:bodyPr wrap="square" lIns="254" tIns="254" rIns="254" bIns="254" rtlCol="0" anchor="ctr">
-            <a:normAutofit/>
-          </a:bodyPr>
-          <a:lstStyle/>
-          <a:p>
-            <a:pPr marL="0" indent="0">
-              <a:buNone/>
-            </a:pPr>
-            <a:r>
-              <a:rPr lang="en-US" sz="1400" dirty="0">
-                <a:solidFill>
-                  <a:srgbClr val="111827"/>
-                </a:solidFill>
-              </a:rPr>
-              <a:t>Krótki horyzont VoG: 5 epok. Wyniki mogą zależeć od liczby checkpointów i batch size.</a:t>
-            </a:r>
-            <a:endParaRPr lang="en-US" sz="1400" dirty="0"/>
-          </a:p>
-        </p:txBody>
-      </p:sp>
-      <p:sp>
-        <p:nvSpPr>
-          <p:cNvPr id="17" name="Shape 15"/>
-          <p:cNvSpPr/>
-          <p:nvPr/>
-        </p:nvSpPr>
-        <p:spPr>
-          <a:xfrm>
-            <a:off x="9372600" y="1325880"/>
-            <a:ext cx="2103120" cy="1920240"/>
-          </a:xfrm>
-          <a:prstGeom prst="roundRect">
-            <a:avLst>
-              <a:gd name="adj" fmla="val 4762"/>
-            </a:avLst>
-          </a:prstGeom>
-          <a:solidFill>
-            <a:srgbClr val="FFFFFF"/>
-          </a:solidFill>
-          <a:ln w="12700">
-            <a:solidFill>
-              <a:srgbClr val="D1D5DB"/>
-            </a:solidFill>
-            <a:prstDash val="solid"/>
-          </a:ln>
-        </p:spPr>
-        <p:txBody>
-          <a:bodyPr/>
-          <a:lstStyle/>
-          <a:p>
-            <a:endParaRPr lang="pl-PL"/>
-          </a:p>
-        </p:txBody>
-      </p:sp>
-      <p:sp>
-        <p:nvSpPr>
-          <p:cNvPr id="18" name="Shape 16"/>
-          <p:cNvSpPr/>
-          <p:nvPr/>
-        </p:nvSpPr>
-        <p:spPr>
-          <a:xfrm>
-            <a:off x="9537192" y="1828800"/>
-            <a:ext cx="1773936" cy="0"/>
-          </a:xfrm>
-          <a:prstGeom prst="line">
-            <a:avLst/>
-          </a:prstGeom>
-          <a:noFill/>
-          <a:ln w="25400">
-            <a:solidFill>
-              <a:srgbClr val="6B7280"/>
-            </a:solidFill>
-            <a:prstDash val="solid"/>
-          </a:ln>
-        </p:spPr>
-        <p:txBody>
-          <a:bodyPr/>
-          <a:lstStyle/>
-          <a:p>
-            <a:endParaRPr lang="pl-PL"/>
-          </a:p>
-        </p:txBody>
-      </p:sp>
-      <p:sp>
-        <p:nvSpPr>
-          <p:cNvPr id="19" name="Text 17"/>
-          <p:cNvSpPr/>
-          <p:nvPr/>
-        </p:nvSpPr>
-        <p:spPr>
-          <a:xfrm>
-            <a:off x="9537192" y="1472184"/>
-            <a:ext cx="1773936" cy="320040"/>
-          </a:xfrm>
-          <a:prstGeom prst="rect">
-            <a:avLst/>
-          </a:prstGeom>
-          <a:noFill/>
-          <a:ln/>
-        </p:spPr>
-        <p:txBody>
-          <a:bodyPr wrap="square" lIns="0" tIns="0" rIns="0" bIns="0" rtlCol="0" anchor="ctr"/>
-          <a:lstStyle/>
-          <a:p>
-            <a:pPr marL="0" indent="0">
-              <a:buNone/>
-            </a:pPr>
-            <a:r>
-              <a:rPr lang="en-US" sz="1500" b="1" dirty="0">
-                <a:solidFill>
-                  <a:srgbClr val="6B7280"/>
-                </a:solidFill>
-              </a:rPr>
-              <a:t>Zakres</a:t>
-            </a:r>
-            <a:endParaRPr lang="en-US" sz="1500" dirty="0"/>
-          </a:p>
-        </p:txBody>
-      </p:sp>
-      <p:sp>
-        <p:nvSpPr>
-          <p:cNvPr id="20" name="Text 18"/>
-          <p:cNvSpPr/>
-          <p:nvPr/>
-        </p:nvSpPr>
-        <p:spPr>
-          <a:xfrm>
-            <a:off x="9537192" y="2039112"/>
-            <a:ext cx="1773936" cy="1097280"/>
-          </a:xfrm>
-          <a:prstGeom prst="rect">
-            <a:avLst/>
-          </a:prstGeom>
-          <a:noFill/>
-          <a:ln/>
-        </p:spPr>
-        <p:txBody>
-          <a:bodyPr wrap="square" lIns="254" tIns="254" rIns="254" bIns="254" rtlCol="0" anchor="ctr">
-            <a:normAutofit/>
-          </a:bodyPr>
-          <a:lstStyle/>
-          <a:p>
-            <a:pPr marL="0" indent="0">
-              <a:buNone/>
-            </a:pPr>
-            <a:r>
-              <a:rPr lang="en-US" sz="1400" dirty="0">
-                <a:solidFill>
-                  <a:srgbClr val="111827"/>
-                </a:solidFill>
-              </a:rPr>
-              <a:t>Nie testujemy memorization / corrupted labels z artykułu.</a:t>
-            </a:r>
-            <a:endParaRPr lang="en-US" sz="1400" dirty="0"/>
-          </a:p>
-        </p:txBody>
-      </p:sp>
-      <p:sp>
-        <p:nvSpPr>
-          <p:cNvPr id="21" name="Shape 19"/>
-          <p:cNvSpPr/>
-          <p:nvPr/>
-        </p:nvSpPr>
-        <p:spPr>
-          <a:xfrm>
-            <a:off x="1005840" y="3977640"/>
-            <a:ext cx="10149840" cy="1325880"/>
-          </a:xfrm>
-          <a:prstGeom prst="roundRect">
-            <a:avLst>
-              <a:gd name="adj" fmla="val 5517"/>
-            </a:avLst>
-          </a:prstGeom>
-          <a:solidFill>
-            <a:srgbClr val="F9FAFB"/>
-          </a:solidFill>
-          <a:ln w="8890">
-            <a:solidFill>
-              <a:srgbClr val="D1D5DB"/>
-            </a:solidFill>
-            <a:prstDash val="solid"/>
-          </a:ln>
-        </p:spPr>
-        <p:txBody>
-          <a:bodyPr/>
-          <a:lstStyle/>
-          <a:p>
-            <a:endParaRPr lang="pl-PL"/>
-          </a:p>
-        </p:txBody>
-      </p:sp>
-      <p:sp>
-        <p:nvSpPr>
-          <p:cNvPr id="22" name="Text 20"/>
-          <p:cNvSpPr/>
-          <p:nvPr/>
-        </p:nvSpPr>
-        <p:spPr>
-          <a:xfrm>
-            <a:off x="1234440" y="4187952"/>
-            <a:ext cx="9692640" cy="228600"/>
-          </a:xfrm>
-          <a:prstGeom prst="rect">
-            <a:avLst/>
-          </a:prstGeom>
-          <a:noFill/>
-          <a:ln/>
-        </p:spPr>
-        <p:txBody>
-          <a:bodyPr wrap="square" lIns="0" tIns="0" rIns="0" bIns="0" rtlCol="0" anchor="ctr"/>
-          <a:lstStyle/>
-          <a:p>
-            <a:pPr marL="0" indent="0" algn="ctr">
-              <a:buNone/>
-            </a:pPr>
-            <a:r>
-              <a:rPr lang="en-US" sz="1500" b="1" dirty="0">
-                <a:solidFill>
-                  <a:srgbClr val="111827"/>
-                </a:solidFill>
-              </a:rPr>
-              <a:t>Najważniejsze następne kroki</a:t>
-            </a:r>
-            <a:endParaRPr lang="en-US" sz="1500" dirty="0"/>
-          </a:p>
-        </p:txBody>
-      </p:sp>
-      <p:sp>
-        <p:nvSpPr>
-          <p:cNvPr id="23" name="Text 21"/>
-          <p:cNvSpPr/>
-          <p:nvPr/>
-        </p:nvSpPr>
-        <p:spPr>
-          <a:xfrm>
-            <a:off x="1325880" y="4617720"/>
-            <a:ext cx="9509760" cy="320040"/>
-          </a:xfrm>
-          <a:prstGeom prst="rect">
-            <a:avLst/>
-          </a:prstGeom>
-          <a:noFill/>
-          <a:ln/>
-        </p:spPr>
-        <p:txBody>
-          <a:bodyPr wrap="square" lIns="0" tIns="0" rIns="0" bIns="0" rtlCol="0" anchor="ctr"/>
-          <a:lstStyle/>
-          <a:p>
-            <a:pPr marL="0" indent="0" algn="ctr">
-              <a:buNone/>
-            </a:pPr>
-            <a:r>
-              <a:rPr lang="en-US" sz="1300" dirty="0">
-                <a:solidFill>
-                  <a:srgbClr val="111827"/>
-                </a:solidFill>
-              </a:rPr>
-              <a:t>1) class-normalized VoG, 2) więcej checkpointów, 3) powtórzenia z losowymi seedami, 4) benchmark OoD/memorization, 5) porównanie z rankingiem reprezentacyjnym DINOv2.</a:t>
-            </a:r>
-            <a:endParaRPr lang="en-US" sz="1300" dirty="0"/>
-          </a:p>
-        </p:txBody>
-      </p:sp>
-      <p:sp>
-        <p:nvSpPr>
-          <p:cNvPr id="24" name="Text 22"/>
-          <p:cNvSpPr/>
-          <p:nvPr/>
-        </p:nvSpPr>
-        <p:spPr>
-          <a:xfrm>
-            <a:off x="594360" y="6547104"/>
-            <a:ext cx="9601200" cy="164592"/>
-          </a:xfrm>
-          <a:prstGeom prst="rect">
-            <a:avLst/>
-          </a:prstGeom>
-          <a:noFill/>
-          <a:ln/>
-        </p:spPr>
-        <p:txBody>
-          <a:bodyPr wrap="square" lIns="0" tIns="0" rIns="0" bIns="0" rtlCol="0" anchor="ctr"/>
-          <a:lstStyle/>
-          <a:p>
-            <a:pPr marL="0" indent="0">
-              <a:buNone/>
-            </a:pPr>
-            <a:r>
-              <a:rPr lang="en-US" sz="780" dirty="0">
-                <a:solidFill>
-                  <a:srgbClr val="6B7280"/>
-                </a:solidFill>
-                <a:latin typeface="Calibri" pitchFamily="34" charset="0"/>
-                <a:ea typeface="Calibri" pitchFamily="34" charset="-122"/>
-                <a:cs typeface="Calibri" pitchFamily="34" charset="-120"/>
-              </a:rPr>
-              <a:t>Ograniczenia wynikają z zakresu projektu i zasobów obliczeniowych</a:t>
-            </a:r>
-            <a:endParaRPr lang="en-US" sz="780" dirty="0"/>
-          </a:p>
-        </p:txBody>
-      </p:sp>
-      <p:sp>
-        <p:nvSpPr>
-          <p:cNvPr id="25" name="Text 23"/>
-          <p:cNvSpPr/>
-          <p:nvPr/>
-        </p:nvSpPr>
-        <p:spPr>
-          <a:xfrm>
-            <a:off x="11338560" y="6547104"/>
-            <a:ext cx="274320" cy="164592"/>
-          </a:xfrm>
-          <a:prstGeom prst="rect">
-            <a:avLst/>
-          </a:prstGeom>
-          <a:noFill/>
-          <a:ln/>
-        </p:spPr>
-        <p:txBody>
-          <a:bodyPr wrap="square" lIns="0" tIns="0" rIns="0" bIns="0" rtlCol="0" anchor="ctr"/>
-          <a:lstStyle/>
-          <a:p>
-            <a:pPr marL="0" indent="0" algn="r">
-              <a:buNone/>
-            </a:pPr>
-            <a:r>
-              <a:rPr lang="en-US" sz="780" dirty="0">
-                <a:solidFill>
-                  <a:srgbClr val="6B7280"/>
-                </a:solidFill>
-                <a:latin typeface="Calibri" pitchFamily="34" charset="0"/>
-                <a:ea typeface="Calibri" pitchFamily="34" charset="-122"/>
-                <a:cs typeface="Calibri" pitchFamily="34" charset="-120"/>
-              </a:rPr>
-              <a:t>15</a:t>
-            </a:r>
-            <a:endParaRPr lang="en-US" sz="780" dirty="0"/>
-          </a:p>
-        </p:txBody>
-      </p:sp>
-    </p:spTree>
-  </p:cSld>
-  <p:clrMapOvr>
-    <a:masterClrMapping/>
-  </p:clrMapOvr>
-</p:sld>
-</file>
-
-<file path=ppt/slides/slide18.xml><?xml version="1.0" encoding="utf-8"?>
-<p:sld xmlns:a="http://schemas.openxmlformats.org/drawingml/2006/main" xmlns:r="http://schemas.openxmlformats.org/officeDocument/2006/relationships" xmlns:p="http://schemas.openxmlformats.org/presentationml/2006/main">
-  <p:cSld name="Slide 16">
-    <p:bg>
-      <p:bgPr>
-        <a:solidFill>
-          <a:srgbClr val="FFFFFF"/>
-        </a:solidFill>
-        <a:effectLst/>
-      </p:bgPr>
-    </p:bg>
-    <p:spTree>
-      <p:nvGrpSpPr>
-        <p:cNvPr id="1" name=""/>
-        <p:cNvGrpSpPr/>
-        <p:nvPr/>
-      </p:nvGrpSpPr>
-      <p:grpSpPr>
-        <a:xfrm>
-          <a:off x="0" y="0"/>
-          <a:ext cx="0" cy="0"/>
-          <a:chOff x="0" y="0"/>
-          <a:chExt cx="0" cy="0"/>
-        </a:xfrm>
-      </p:grpSpPr>
-      <p:sp>
-        <p:nvSpPr>
-          <p:cNvPr id="2" name="Shape 0"/>
-          <p:cNvSpPr/>
-          <p:nvPr/>
-        </p:nvSpPr>
-        <p:spPr>
-          <a:xfrm>
-            <a:off x="594360" y="6473952"/>
-            <a:ext cx="10972800" cy="0"/>
-          </a:xfrm>
-          <a:prstGeom prst="line">
-            <a:avLst/>
-          </a:prstGeom>
-          <a:noFill/>
-          <a:ln w="6350">
-            <a:solidFill>
-              <a:srgbClr val="D1D5DB"/>
-            </a:solidFill>
-            <a:prstDash val="solid"/>
-          </a:ln>
-        </p:spPr>
-        <p:txBody>
-          <a:bodyPr/>
-          <a:lstStyle/>
-          <a:p>
-            <a:endParaRPr lang="pl-PL"/>
-          </a:p>
-        </p:txBody>
-      </p:sp>
-      <p:sp>
-        <p:nvSpPr>
-          <p:cNvPr id="3" name="Text 1"/>
-          <p:cNvSpPr/>
-          <p:nvPr/>
-        </p:nvSpPr>
-        <p:spPr>
-          <a:xfrm>
-            <a:off x="594360" y="292608"/>
-            <a:ext cx="10972800" cy="502920"/>
-          </a:xfrm>
-          <a:prstGeom prst="rect">
-            <a:avLst/>
-          </a:prstGeom>
-          <a:noFill/>
-          <a:ln/>
-        </p:spPr>
-        <p:txBody>
-          <a:bodyPr wrap="square" lIns="0" tIns="0" rIns="0" bIns="0" rtlCol="0" anchor="ctr"/>
-          <a:lstStyle/>
-          <a:p>
-            <a:pPr marL="0" indent="0">
-              <a:buNone/>
-            </a:pPr>
-            <a:r>
-              <a:rPr lang="en-US" sz="3000" dirty="0">
-                <a:solidFill>
-                  <a:srgbClr val="000000"/>
-                </a:solidFill>
-                <a:latin typeface="Calibri" pitchFamily="34" charset="0"/>
-                <a:ea typeface="Calibri" pitchFamily="34" charset="-122"/>
-                <a:cs typeface="Calibri" pitchFamily="34" charset="-120"/>
-              </a:rPr>
-              <a:t>Wniosek końcowy</a:t>
-            </a:r>
-            <a:endParaRPr lang="en-US" sz="3000" dirty="0"/>
-          </a:p>
-        </p:txBody>
-      </p:sp>
-      <p:sp>
-        <p:nvSpPr>
-          <p:cNvPr id="4" name="Text 2"/>
-          <p:cNvSpPr/>
-          <p:nvPr/>
-        </p:nvSpPr>
-        <p:spPr>
-          <a:xfrm>
-            <a:off x="603504" y="850392"/>
-            <a:ext cx="10698480" cy="329184"/>
-          </a:xfrm>
-          <a:prstGeom prst="rect">
-            <a:avLst/>
-          </a:prstGeom>
-          <a:noFill/>
-          <a:ln/>
-        </p:spPr>
-        <p:txBody>
-          <a:bodyPr wrap="square" lIns="0" tIns="0" rIns="0" bIns="0" rtlCol="0" anchor="ctr"/>
-          <a:lstStyle/>
-          <a:p>
-            <a:pPr marL="0" indent="0">
-              <a:buNone/>
-            </a:pPr>
-            <a:r>
-              <a:rPr lang="en-US" sz="1250" dirty="0">
-                <a:solidFill>
-                  <a:srgbClr val="6B7280"/>
-                </a:solidFill>
-                <a:latin typeface="Calibri" pitchFamily="34" charset="0"/>
-                <a:ea typeface="Calibri" pitchFamily="34" charset="-122"/>
-                <a:cs typeface="Calibri" pitchFamily="34" charset="-120"/>
-              </a:rPr>
-              <a:t>Czy hipotezy z artykułu znajdują potwierdzenie?</a:t>
-            </a:r>
-            <a:endParaRPr lang="en-US" sz="1250" dirty="0"/>
-          </a:p>
-        </p:txBody>
-      </p:sp>
-      <p:sp>
-        <p:nvSpPr>
-          <p:cNvPr id="5" name="Text 3"/>
-          <p:cNvSpPr/>
-          <p:nvPr/>
-        </p:nvSpPr>
-        <p:spPr>
-          <a:xfrm>
-            <a:off x="1051560" y="1417320"/>
-            <a:ext cx="10058400" cy="658368"/>
-          </a:xfrm>
-          <a:prstGeom prst="rect">
-            <a:avLst/>
-          </a:prstGeom>
-          <a:noFill/>
-          <a:ln/>
-        </p:spPr>
-        <p:txBody>
-          <a:bodyPr wrap="square" lIns="0" tIns="0" rIns="0" bIns="0" rtlCol="0" anchor="ctr"/>
-          <a:lstStyle/>
-          <a:p>
-            <a:pPr marL="0" indent="0" algn="ctr">
-              <a:buNone/>
-            </a:pPr>
-            <a:r>
-              <a:rPr lang="en-US" sz="3800" b="1" dirty="0">
-                <a:solidFill>
-                  <a:srgbClr val="F59E0B"/>
-                </a:solidFill>
-              </a:rPr>
-              <a:t>CZĘŚCIOWO TAK</a:t>
-            </a:r>
-            <a:endParaRPr lang="en-US" sz="3800" dirty="0"/>
-          </a:p>
-        </p:txBody>
-      </p:sp>
-      <p:sp>
-        <p:nvSpPr>
-          <p:cNvPr id="6" name="Shape 4"/>
-          <p:cNvSpPr/>
-          <p:nvPr/>
-        </p:nvSpPr>
-        <p:spPr>
-          <a:xfrm>
-            <a:off x="868680" y="2423160"/>
-            <a:ext cx="3383280" cy="2057400"/>
-          </a:xfrm>
-          <a:prstGeom prst="roundRect">
-            <a:avLst>
-              <a:gd name="adj" fmla="val 4444"/>
-            </a:avLst>
-          </a:prstGeom>
-          <a:solidFill>
-            <a:srgbClr val="FFFFFF"/>
-          </a:solidFill>
-          <a:ln w="12700">
-            <a:solidFill>
-              <a:srgbClr val="D1D5DB"/>
-            </a:solidFill>
-            <a:prstDash val="solid"/>
-          </a:ln>
-        </p:spPr>
-        <p:txBody>
-          <a:bodyPr/>
-          <a:lstStyle/>
-          <a:p>
-            <a:endParaRPr lang="pl-PL"/>
-          </a:p>
-        </p:txBody>
-      </p:sp>
-      <p:sp>
-        <p:nvSpPr>
-          <p:cNvPr id="7" name="Shape 5"/>
-          <p:cNvSpPr/>
-          <p:nvPr/>
-        </p:nvSpPr>
-        <p:spPr>
-          <a:xfrm>
-            <a:off x="1033272" y="2926080"/>
-            <a:ext cx="3054096" cy="0"/>
-          </a:xfrm>
-          <a:prstGeom prst="line">
-            <a:avLst/>
-          </a:prstGeom>
-          <a:noFill/>
-          <a:ln w="25400">
-            <a:solidFill>
-              <a:srgbClr val="22C55E"/>
-            </a:solidFill>
-            <a:prstDash val="solid"/>
-          </a:ln>
-        </p:spPr>
-        <p:txBody>
-          <a:bodyPr/>
-          <a:lstStyle/>
-          <a:p>
-            <a:endParaRPr lang="pl-PL"/>
-          </a:p>
-        </p:txBody>
-      </p:sp>
-      <p:sp>
-        <p:nvSpPr>
-          <p:cNvPr id="8" name="Text 6"/>
-          <p:cNvSpPr/>
-          <p:nvPr/>
-        </p:nvSpPr>
-        <p:spPr>
-          <a:xfrm>
-            <a:off x="1033272" y="2569464"/>
-            <a:ext cx="3054096" cy="320040"/>
-          </a:xfrm>
-          <a:prstGeom prst="rect">
-            <a:avLst/>
-          </a:prstGeom>
-          <a:noFill/>
-          <a:ln/>
-        </p:spPr>
-        <p:txBody>
-          <a:bodyPr wrap="square" lIns="0" tIns="0" rIns="0" bIns="0" rtlCol="0" anchor="ctr"/>
-          <a:lstStyle/>
-          <a:p>
-            <a:pPr marL="0" indent="0">
-              <a:buNone/>
-            </a:pPr>
-            <a:r>
-              <a:rPr lang="en-US" sz="1500" b="1" dirty="0">
-                <a:solidFill>
-                  <a:srgbClr val="22C55E"/>
-                </a:solidFill>
-              </a:rPr>
-              <a:t>1. Informatywność</a:t>
-            </a:r>
-            <a:endParaRPr lang="en-US" sz="1500" dirty="0"/>
-          </a:p>
-        </p:txBody>
-      </p:sp>
-      <p:sp>
-        <p:nvSpPr>
-          <p:cNvPr id="9" name="Text 7"/>
-          <p:cNvSpPr/>
-          <p:nvPr/>
-        </p:nvSpPr>
-        <p:spPr>
-          <a:xfrm>
-            <a:off x="1033272" y="3136392"/>
-            <a:ext cx="3054096" cy="1234440"/>
-          </a:xfrm>
-          <a:prstGeom prst="rect">
-            <a:avLst/>
-          </a:prstGeom>
-          <a:noFill/>
-          <a:ln/>
-        </p:spPr>
-        <p:txBody>
-          <a:bodyPr wrap="square" lIns="254" tIns="254" rIns="254" bIns="254" rtlCol="0" anchor="ctr">
-            <a:normAutofit/>
-          </a:bodyPr>
-          <a:lstStyle/>
-          <a:p>
-            <a:pPr marL="0" indent="0">
-              <a:buNone/>
-            </a:pPr>
-            <a:r>
-              <a:rPr lang="en-US" sz="1400" dirty="0">
-                <a:solidFill>
-                  <a:srgbClr val="111827"/>
-                </a:solidFill>
-              </a:rPr>
-              <a:t>High-VoG 30% zachowuje znacznie więcej sygnału niż Low-VoG 30%. To jest najstabilniejszy wynik projektu.</a:t>
-            </a:r>
-            <a:endParaRPr lang="en-US" sz="1400" dirty="0"/>
-          </a:p>
-        </p:txBody>
-      </p:sp>
-      <p:sp>
-        <p:nvSpPr>
-          <p:cNvPr id="10" name="Shape 8"/>
-          <p:cNvSpPr/>
-          <p:nvPr/>
-        </p:nvSpPr>
-        <p:spPr>
-          <a:xfrm>
-            <a:off x="4389120" y="2423160"/>
-            <a:ext cx="3383280" cy="2057400"/>
-          </a:xfrm>
-          <a:prstGeom prst="roundRect">
-            <a:avLst>
-              <a:gd name="adj" fmla="val 4444"/>
-            </a:avLst>
-          </a:prstGeom>
-          <a:solidFill>
-            <a:srgbClr val="FFFFFF"/>
-          </a:solidFill>
-          <a:ln w="12700">
-            <a:solidFill>
-              <a:srgbClr val="D1D5DB"/>
-            </a:solidFill>
-            <a:prstDash val="solid"/>
-          </a:ln>
-        </p:spPr>
-        <p:txBody>
-          <a:bodyPr/>
-          <a:lstStyle/>
-          <a:p>
-            <a:endParaRPr lang="pl-PL"/>
-          </a:p>
-        </p:txBody>
-      </p:sp>
-      <p:sp>
-        <p:nvSpPr>
-          <p:cNvPr id="11" name="Shape 9"/>
-          <p:cNvSpPr/>
-          <p:nvPr/>
-        </p:nvSpPr>
-        <p:spPr>
-          <a:xfrm>
-            <a:off x="4553712" y="2926080"/>
-            <a:ext cx="3054096" cy="0"/>
-          </a:xfrm>
-          <a:prstGeom prst="line">
-            <a:avLst/>
-          </a:prstGeom>
-          <a:noFill/>
-          <a:ln w="25400">
-            <a:solidFill>
-              <a:srgbClr val="3B82F6"/>
-            </a:solidFill>
-            <a:prstDash val="solid"/>
-          </a:ln>
-        </p:spPr>
-        <p:txBody>
-          <a:bodyPr/>
-          <a:lstStyle/>
-          <a:p>
-            <a:endParaRPr lang="pl-PL"/>
-          </a:p>
-        </p:txBody>
-      </p:sp>
-      <p:sp>
-        <p:nvSpPr>
-          <p:cNvPr id="12" name="Text 10"/>
-          <p:cNvSpPr/>
-          <p:nvPr/>
-        </p:nvSpPr>
-        <p:spPr>
-          <a:xfrm>
-            <a:off x="4553712" y="2569464"/>
-            <a:ext cx="3054096" cy="320040"/>
-          </a:xfrm>
-          <a:prstGeom prst="rect">
-            <a:avLst/>
-          </a:prstGeom>
-          <a:noFill/>
-          <a:ln/>
-        </p:spPr>
-        <p:txBody>
-          <a:bodyPr wrap="square" lIns="0" tIns="0" rIns="0" bIns="0" rtlCol="0" anchor="ctr"/>
-          <a:lstStyle/>
-          <a:p>
-            <a:pPr marL="0" indent="0">
-              <a:buNone/>
-            </a:pPr>
-            <a:r>
-              <a:rPr lang="en-US" sz="1500" b="1" dirty="0">
-                <a:solidFill>
-                  <a:srgbClr val="3B82F6"/>
-                </a:solidFill>
-              </a:rPr>
-              <a:t>2. Efektywność danych</a:t>
-            </a:r>
-            <a:endParaRPr lang="en-US" sz="1500" dirty="0"/>
-          </a:p>
-        </p:txBody>
-      </p:sp>
-      <p:sp>
-        <p:nvSpPr>
-          <p:cNvPr id="13" name="Text 11"/>
-          <p:cNvSpPr/>
-          <p:nvPr/>
-        </p:nvSpPr>
-        <p:spPr>
-          <a:xfrm>
-            <a:off x="4553712" y="3136392"/>
-            <a:ext cx="3054096" cy="1234440"/>
-          </a:xfrm>
-          <a:prstGeom prst="rect">
-            <a:avLst/>
-          </a:prstGeom>
-          <a:noFill/>
-          <a:ln/>
-        </p:spPr>
-        <p:txBody>
-          <a:bodyPr wrap="square" lIns="254" tIns="254" rIns="254" bIns="254" rtlCol="0" anchor="ctr">
-            <a:normAutofit/>
-          </a:bodyPr>
-          <a:lstStyle/>
-          <a:p>
-            <a:pPr marL="0" indent="0">
-              <a:buNone/>
-            </a:pPr>
-            <a:r>
-              <a:rPr lang="en-US" sz="1400" dirty="0">
-                <a:solidFill>
-                  <a:srgbClr val="111827"/>
-                </a:solidFill>
-              </a:rPr>
-              <a:t>W Phase 2 Top 30% prawie dorównuje full dataset. W trudniejszym fine-tuningu od zera full dataset nadal wygrywa.</a:t>
-            </a:r>
-            <a:endParaRPr lang="en-US" sz="1400" dirty="0"/>
-          </a:p>
-        </p:txBody>
-      </p:sp>
-      <p:sp>
-        <p:nvSpPr>
-          <p:cNvPr id="14" name="Shape 12"/>
-          <p:cNvSpPr/>
-          <p:nvPr/>
-        </p:nvSpPr>
-        <p:spPr>
-          <a:xfrm>
-            <a:off x="7909560" y="2423160"/>
-            <a:ext cx="3383280" cy="2057400"/>
-          </a:xfrm>
-          <a:prstGeom prst="roundRect">
-            <a:avLst>
-              <a:gd name="adj" fmla="val 4444"/>
-            </a:avLst>
-          </a:prstGeom>
-          <a:solidFill>
-            <a:srgbClr val="FFFFFF"/>
-          </a:solidFill>
-          <a:ln w="12700">
-            <a:solidFill>
-              <a:srgbClr val="D1D5DB"/>
-            </a:solidFill>
-            <a:prstDash val="solid"/>
-          </a:ln>
-        </p:spPr>
-        <p:txBody>
-          <a:bodyPr/>
-          <a:lstStyle/>
-          <a:p>
-            <a:endParaRPr lang="pl-PL"/>
-          </a:p>
-        </p:txBody>
-      </p:sp>
-      <p:sp>
-        <p:nvSpPr>
-          <p:cNvPr id="15" name="Shape 13"/>
-          <p:cNvSpPr/>
-          <p:nvPr/>
-        </p:nvSpPr>
-        <p:spPr>
-          <a:xfrm>
-            <a:off x="8074152" y="2926080"/>
-            <a:ext cx="3054096" cy="0"/>
-          </a:xfrm>
-          <a:prstGeom prst="line">
-            <a:avLst/>
-          </a:prstGeom>
-          <a:noFill/>
-          <a:ln w="25400">
-            <a:solidFill>
-              <a:srgbClr val="8B5CF6"/>
-            </a:solidFill>
-            <a:prstDash val="solid"/>
-          </a:ln>
-        </p:spPr>
-        <p:txBody>
-          <a:bodyPr/>
-          <a:lstStyle/>
-          <a:p>
-            <a:endParaRPr lang="pl-PL"/>
-          </a:p>
-        </p:txBody>
-      </p:sp>
-      <p:sp>
-        <p:nvSpPr>
-          <p:cNvPr id="16" name="Text 14"/>
-          <p:cNvSpPr/>
-          <p:nvPr/>
-        </p:nvSpPr>
-        <p:spPr>
-          <a:xfrm>
-            <a:off x="8074152" y="2569464"/>
-            <a:ext cx="3054096" cy="320040"/>
-          </a:xfrm>
-          <a:prstGeom prst="rect">
-            <a:avLst/>
-          </a:prstGeom>
-          <a:noFill/>
-          <a:ln/>
-        </p:spPr>
-        <p:txBody>
-          <a:bodyPr wrap="square" lIns="0" tIns="0" rIns="0" bIns="0" rtlCol="0" anchor="ctr"/>
-          <a:lstStyle/>
-          <a:p>
-            <a:pPr marL="0" indent="0">
-              <a:buNone/>
-            </a:pPr>
-            <a:r>
-              <a:rPr lang="en-US" sz="1500" b="1" dirty="0">
-                <a:solidFill>
-                  <a:srgbClr val="8B5CF6"/>
-                </a:solidFill>
-              </a:rPr>
-              <a:t>3. Transfer</a:t>
-            </a:r>
-            <a:endParaRPr lang="en-US" sz="1500" dirty="0"/>
-          </a:p>
-        </p:txBody>
-      </p:sp>
-      <p:sp>
-        <p:nvSpPr>
-          <p:cNvPr id="17" name="Text 15"/>
-          <p:cNvSpPr/>
-          <p:nvPr/>
-        </p:nvSpPr>
-        <p:spPr>
-          <a:xfrm>
-            <a:off x="8074152" y="3136392"/>
-            <a:ext cx="3054096" cy="1234440"/>
-          </a:xfrm>
-          <a:prstGeom prst="rect">
-            <a:avLst/>
-          </a:prstGeom>
-          <a:noFill/>
-          <a:ln/>
-        </p:spPr>
-        <p:txBody>
-          <a:bodyPr wrap="square" lIns="254" tIns="254" rIns="254" bIns="254" rtlCol="0" anchor="ctr">
-            <a:normAutofit/>
-          </a:bodyPr>
-          <a:lstStyle/>
-          <a:p>
-            <a:pPr marL="0" indent="0">
-              <a:buNone/>
-            </a:pPr>
-            <a:r>
-              <a:rPr lang="en-US" sz="1400" dirty="0">
-                <a:solidFill>
-                  <a:srgbClr val="111827"/>
-                </a:solidFill>
-              </a:rPr>
-              <a:t>Ranking przenosi się umiarkowanie dobrze w pretrained, ale słabo w from-scratch. Uniwersalność zależy od reżimu.</a:t>
-            </a:r>
-            <a:endParaRPr lang="en-US" sz="1400" dirty="0"/>
-          </a:p>
-        </p:txBody>
-      </p:sp>
-      <p:sp>
-        <p:nvSpPr>
-          <p:cNvPr id="18" name="Shape 16"/>
-          <p:cNvSpPr/>
-          <p:nvPr/>
-        </p:nvSpPr>
-        <p:spPr>
-          <a:xfrm>
-            <a:off x="1005840" y="5074920"/>
-            <a:ext cx="10149840" cy="822960"/>
-          </a:xfrm>
-          <a:prstGeom prst="roundRect">
-            <a:avLst>
-              <a:gd name="adj" fmla="val 8889"/>
-            </a:avLst>
-          </a:prstGeom>
-          <a:solidFill>
-            <a:srgbClr val="F3F4F6"/>
-          </a:solidFill>
-          <a:ln w="7620">
-            <a:solidFill>
-              <a:srgbClr val="D1D5DB"/>
-            </a:solidFill>
-            <a:prstDash val="solid"/>
-          </a:ln>
-        </p:spPr>
-        <p:txBody>
-          <a:bodyPr/>
-          <a:lstStyle/>
-          <a:p>
-            <a:endParaRPr lang="pl-PL"/>
-          </a:p>
-        </p:txBody>
-      </p:sp>
-      <p:sp>
-        <p:nvSpPr>
-          <p:cNvPr id="19" name="Text 17"/>
-          <p:cNvSpPr/>
-          <p:nvPr/>
-        </p:nvSpPr>
-        <p:spPr>
-          <a:xfrm>
-            <a:off x="1188720" y="5230368"/>
-            <a:ext cx="822960" cy="182880"/>
-          </a:xfrm>
-          <a:prstGeom prst="rect">
-            <a:avLst/>
-          </a:prstGeom>
-          <a:noFill/>
-          <a:ln/>
-        </p:spPr>
-        <p:txBody>
-          <a:bodyPr wrap="square" lIns="0" tIns="0" rIns="0" bIns="0" rtlCol="0" anchor="ctr"/>
-          <a:lstStyle/>
-          <a:p>
-            <a:pPr marL="0" indent="0">
-              <a:buNone/>
-            </a:pPr>
-            <a:r>
-              <a:rPr lang="en-US" sz="1150" b="1" dirty="0">
-                <a:solidFill>
-                  <a:srgbClr val="111827"/>
-                </a:solidFill>
-              </a:rPr>
-              <a:t>Źródła</a:t>
-            </a:r>
-            <a:endParaRPr lang="en-US" sz="1150" dirty="0"/>
-          </a:p>
-        </p:txBody>
-      </p:sp>
-      <p:sp>
-        <p:nvSpPr>
-          <p:cNvPr id="20" name="Text 18"/>
-          <p:cNvSpPr/>
-          <p:nvPr/>
-        </p:nvSpPr>
-        <p:spPr>
-          <a:xfrm>
-            <a:off x="2057400" y="5230368"/>
-            <a:ext cx="8961120" cy="411480"/>
-          </a:xfrm>
-          <a:prstGeom prst="rect">
-            <a:avLst/>
-          </a:prstGeom>
-          <a:noFill/>
-          <a:ln/>
-        </p:spPr>
-        <p:txBody>
-          <a:bodyPr wrap="square" lIns="0" tIns="0" rIns="0" bIns="0" rtlCol="0" anchor="ctr">
-            <a:normAutofit/>
-          </a:bodyPr>
-          <a:lstStyle/>
-          <a:p>
-            <a:pPr marL="0" indent="0">
-              <a:buNone/>
-            </a:pPr>
-            <a:r>
-              <a:rPr lang="en-US" sz="980" dirty="0">
-                <a:solidFill>
-                  <a:srgbClr val="111827"/>
-                </a:solidFill>
-              </a:rPr>
-              <a:t>Agarwal et al. 2022, arXiv:2008.11600  •  phase2_WB2_wyniki.ipynb  •  phqse3_WB2 — kopia — kopia.ipynb  •  pahse3_WB2_od_zera.ipynb  •  github.com/Fichey/Impact-of-Data-Ranking-on-Training-Dynamics</a:t>
-            </a:r>
-            <a:endParaRPr lang="en-US" sz="980" dirty="0"/>
-          </a:p>
-        </p:txBody>
-      </p:sp>
-      <p:sp>
-        <p:nvSpPr>
-          <p:cNvPr id="21" name="Text 19"/>
-          <p:cNvSpPr/>
-          <p:nvPr/>
-        </p:nvSpPr>
-        <p:spPr>
-          <a:xfrm>
-            <a:off x="1005840" y="6053328"/>
-            <a:ext cx="10058400" cy="228600"/>
-          </a:xfrm>
-          <a:prstGeom prst="rect">
-            <a:avLst/>
-          </a:prstGeom>
-          <a:noFill/>
-          <a:ln/>
-        </p:spPr>
-        <p:txBody>
-          <a:bodyPr wrap="square" lIns="0" tIns="0" rIns="0" bIns="0" rtlCol="0" anchor="ctr"/>
-          <a:lstStyle/>
-          <a:p>
-            <a:pPr marL="0" indent="0" algn="ctr">
-              <a:buNone/>
-            </a:pPr>
-            <a:r>
-              <a:rPr lang="en-US" sz="1250" dirty="0">
-                <a:solidFill>
-                  <a:srgbClr val="6B7280"/>
-                </a:solidFill>
-              </a:rPr>
-              <a:t>Prezentacja gotowa do obrony: mało tekstu na slajdach, wykresy/tabele jako główny nośnik argumentacji.</a:t>
-            </a:r>
-            <a:endParaRPr lang="en-US" sz="1250" dirty="0"/>
-          </a:p>
-        </p:txBody>
-      </p:sp>
-      <p:sp>
-        <p:nvSpPr>
-          <p:cNvPr id="22" name="Text 20"/>
-          <p:cNvSpPr/>
-          <p:nvPr/>
-        </p:nvSpPr>
-        <p:spPr>
-          <a:xfrm>
-            <a:off x="594360" y="6547104"/>
-            <a:ext cx="9601200" cy="164592"/>
-          </a:xfrm>
-          <a:prstGeom prst="rect">
-            <a:avLst/>
-          </a:prstGeom>
-          <a:noFill/>
-          <a:ln/>
-        </p:spPr>
-        <p:txBody>
-          <a:bodyPr wrap="square" lIns="0" tIns="0" rIns="0" bIns="0" rtlCol="0" anchor="ctr"/>
-          <a:lstStyle/>
-          <a:p>
-            <a:pPr marL="0" indent="0">
-              <a:buNone/>
-            </a:pPr>
-            <a:r>
-              <a:rPr lang="en-US" sz="780" dirty="0">
-                <a:solidFill>
-                  <a:srgbClr val="6B7280"/>
-                </a:solidFill>
-                <a:latin typeface="Calibri" pitchFamily="34" charset="0"/>
-                <a:ea typeface="Calibri" pitchFamily="34" charset="-122"/>
-                <a:cs typeface="Calibri" pitchFamily="34" charset="-120"/>
-              </a:rPr>
-              <a:t>Podsumowanie końcowe</a:t>
-            </a:r>
-            <a:endParaRPr lang="en-US" sz="780" dirty="0"/>
-          </a:p>
-        </p:txBody>
-      </p:sp>
-      <p:sp>
-        <p:nvSpPr>
-          <p:cNvPr id="23" name="Text 21"/>
-          <p:cNvSpPr/>
-          <p:nvPr/>
-        </p:nvSpPr>
-        <p:spPr>
-          <a:xfrm>
-            <a:off x="11338560" y="6547104"/>
-            <a:ext cx="274320" cy="164592"/>
-          </a:xfrm>
-          <a:prstGeom prst="rect">
-            <a:avLst/>
-          </a:prstGeom>
-          <a:noFill/>
-          <a:ln/>
-        </p:spPr>
-        <p:txBody>
-          <a:bodyPr wrap="square" lIns="0" tIns="0" rIns="0" bIns="0" rtlCol="0" anchor="ctr"/>
-          <a:lstStyle/>
-          <a:p>
-            <a:pPr marL="0" indent="0" algn="r">
-              <a:buNone/>
-            </a:pPr>
-            <a:r>
-              <a:rPr lang="en-US" sz="780" dirty="0">
-                <a:solidFill>
-                  <a:srgbClr val="6B7280"/>
-                </a:solidFill>
-                <a:latin typeface="Calibri" pitchFamily="34" charset="0"/>
-                <a:ea typeface="Calibri" pitchFamily="34" charset="-122"/>
-                <a:cs typeface="Calibri" pitchFamily="34" charset="-120"/>
-              </a:rPr>
-              <a:t>16</a:t>
             </a:r>
             <a:endParaRPr lang="en-US" sz="780" dirty="0"/>
           </a:p>
@@ -8434,7 +7350,7 @@
         </p:nvSpPr>
         <p:spPr>
           <a:xfrm>
-            <a:off x="777240" y="1417320"/>
+            <a:off x="1527738" y="1746504"/>
             <a:ext cx="2834640" cy="658368"/>
           </a:xfrm>
           <a:prstGeom prst="roundRect">
@@ -8468,7 +7384,7 @@
         </p:nvSpPr>
         <p:spPr>
           <a:xfrm>
-            <a:off x="941832" y="1609344"/>
+            <a:off x="1692330" y="1938528"/>
             <a:ext cx="2468880" cy="228600"/>
           </a:xfrm>
           <a:prstGeom prst="rect">
@@ -8512,7 +7428,7 @@
         </p:blipFill>
         <p:spPr>
           <a:xfrm>
-            <a:off x="4780649" y="1389888"/>
+            <a:off x="5531147" y="1719072"/>
             <a:ext cx="5251981" cy="713232"/>
           </a:xfrm>
           <a:prstGeom prst="rect">
@@ -8528,7 +7444,7 @@
         </p:nvSpPr>
         <p:spPr>
           <a:xfrm>
-            <a:off x="777240" y="2331720"/>
+            <a:off x="1527738" y="2660904"/>
             <a:ext cx="2834640" cy="658368"/>
           </a:xfrm>
           <a:prstGeom prst="roundRect">
@@ -8562,7 +7478,7 @@
         </p:nvSpPr>
         <p:spPr>
           <a:xfrm>
-            <a:off x="941832" y="2523744"/>
+            <a:off x="1692330" y="2852928"/>
             <a:ext cx="2468880" cy="228600"/>
           </a:xfrm>
           <a:prstGeom prst="rect">
@@ -8606,7 +7522,7 @@
         </p:blipFill>
         <p:spPr>
           <a:xfrm>
-            <a:off x="5621989" y="2304288"/>
+            <a:off x="6372487" y="2633472"/>
             <a:ext cx="3569302" cy="713232"/>
           </a:xfrm>
           <a:prstGeom prst="rect">
@@ -8622,7 +7538,7 @@
         </p:nvSpPr>
         <p:spPr>
           <a:xfrm>
-            <a:off x="777240" y="3337560"/>
+            <a:off x="1527738" y="3666744"/>
             <a:ext cx="2834640" cy="658368"/>
           </a:xfrm>
           <a:prstGeom prst="roundRect">
@@ -8656,7 +7572,7 @@
         </p:nvSpPr>
         <p:spPr>
           <a:xfrm>
-            <a:off x="941832" y="3529584"/>
+            <a:off x="1692330" y="3858768"/>
             <a:ext cx="2468880" cy="228600"/>
           </a:xfrm>
           <a:prstGeom prst="rect">
@@ -8700,7 +7616,7 @@
         </p:blipFill>
         <p:spPr>
           <a:xfrm>
-            <a:off x="4688284" y="3310128"/>
+            <a:off x="5438782" y="3639312"/>
             <a:ext cx="5436712" cy="713232"/>
           </a:xfrm>
           <a:prstGeom prst="rect">
@@ -8716,7 +7632,7 @@
         </p:nvSpPr>
         <p:spPr>
           <a:xfrm>
-            <a:off x="777240" y="4343400"/>
+            <a:off x="1527738" y="4672584"/>
             <a:ext cx="2834640" cy="658368"/>
           </a:xfrm>
           <a:prstGeom prst="roundRect">
@@ -8750,7 +7666,7 @@
         </p:nvSpPr>
         <p:spPr>
           <a:xfrm>
-            <a:off x="941832" y="4535424"/>
+            <a:off x="1692330" y="4864608"/>
             <a:ext cx="2468880" cy="228600"/>
           </a:xfrm>
           <a:prstGeom prst="rect">
@@ -8794,7 +7710,7 @@
         </p:blipFill>
         <p:spPr>
           <a:xfrm>
-            <a:off x="5448274" y="4315968"/>
+            <a:off x="6198772" y="4645152"/>
             <a:ext cx="3916732" cy="713232"/>
           </a:xfrm>
           <a:prstGeom prst="rect">
@@ -8945,45 +7861,6 @@
       </p:sp>
       <p:sp>
         <p:nvSpPr>
-          <p:cNvPr id="4" name="Text 2"/>
-          <p:cNvSpPr/>
-          <p:nvPr/>
-        </p:nvSpPr>
-        <p:spPr>
-          <a:xfrm>
-            <a:off x="603504" y="850392"/>
-            <a:ext cx="10698480" cy="329184"/>
-          </a:xfrm>
-          <a:prstGeom prst="rect">
-            <a:avLst/>
-          </a:prstGeom>
-          <a:noFill/>
-          <a:ln/>
-        </p:spPr>
-        <p:txBody>
-          <a:bodyPr wrap="square" lIns="0" tIns="0" rIns="0" bIns="0" rtlCol="0" anchor="ctr"/>
-          <a:lstStyle/>
-          <a:p>
-            <a:pPr marL="0" indent="0">
-              <a:buNone/>
-            </a:pPr>
-            <a:r>
-              <a:rPr lang="en-US" sz="1250" dirty="0">
-                <a:solidFill>
-                  <a:srgbClr val="6B7280"/>
-                </a:solidFill>
-                <a:latin typeface="Calibri" pitchFamily="34" charset="0"/>
-                <a:ea typeface="Calibri" pitchFamily="34" charset="-122"/>
-                <a:cs typeface="Calibri" pitchFamily="34" charset="-120"/>
-              </a:rPr>
-              <a:t>Zgodnie z poleceniem projektu: baseline + porównanie podzbiorów + transfer architektury.</a:t>
-            </a:r>
-            <a:endParaRPr lang="en-US" sz="1250" dirty="0"/>
-          </a:p>
-        </p:txBody>
-      </p:sp>
-      <p:sp>
-        <p:nvSpPr>
           <p:cNvPr id="5" name="Shape 3"/>
           <p:cNvSpPr/>
           <p:nvPr/>
@@ -10321,7 +9198,7 @@
 
 <file path=ppt/slides/slide6.xml><?xml version="1.0" encoding="utf-8"?>
 <p:sld xmlns:a="http://schemas.openxmlformats.org/drawingml/2006/main" xmlns:r="http://schemas.openxmlformats.org/officeDocument/2006/relationships" xmlns:p="http://schemas.openxmlformats.org/presentationml/2006/main">
-  <p:cSld name="Slide 7">
+  <p:cSld>
     <p:bg>
       <p:bgPr>
         <a:solidFill>
@@ -10332,7 +9209,13 @@
     </p:bg>
     <p:spTree>
       <p:nvGrpSpPr>
-        <p:cNvPr id="1" name=""/>
+        <p:cNvPr id="1" name="">
+          <a:extLst>
+            <a:ext uri="{FF2B5EF4-FFF2-40B4-BE49-F238E27FC236}">
+              <a16:creationId xmlns:a16="http://schemas.microsoft.com/office/drawing/2014/main" id="{18E3B2C0-5A1E-6874-F5D5-480085503B9F}"/>
+            </a:ext>
+          </a:extLst>
+        </p:cNvPr>
         <p:cNvGrpSpPr/>
         <p:nvPr/>
       </p:nvGrpSpPr>
@@ -10346,7 +9229,13 @@
       </p:grpSpPr>
       <p:sp>
         <p:nvSpPr>
-          <p:cNvPr id="2" name="Shape 0"/>
+          <p:cNvPr id="2" name="Shape 0">
+            <a:extLst>
+              <a:ext uri="{FF2B5EF4-FFF2-40B4-BE49-F238E27FC236}">
+                <a16:creationId xmlns:a16="http://schemas.microsoft.com/office/drawing/2014/main" id="{9F687FDE-1037-4B8D-FF8F-E03407C9938B}"/>
+              </a:ext>
+            </a:extLst>
+          </p:cNvPr>
           <p:cNvSpPr/>
           <p:nvPr/>
         </p:nvSpPr>
@@ -10376,7 +9265,13 @@
       </p:sp>
       <p:sp>
         <p:nvSpPr>
-          <p:cNvPr id="3" name="Text 1"/>
+          <p:cNvPr id="3" name="Text 1">
+            <a:extLst>
+              <a:ext uri="{FF2B5EF4-FFF2-40B4-BE49-F238E27FC236}">
+                <a16:creationId xmlns:a16="http://schemas.microsoft.com/office/drawing/2014/main" id="{A262BD49-58E5-A4D2-ED69-91C766F67DF8}"/>
+              </a:ext>
+            </a:extLst>
+          </p:cNvPr>
           <p:cNvSpPr/>
           <p:nvPr/>
         </p:nvSpPr>
@@ -10415,7 +9310,13 @@
       </p:sp>
       <p:sp>
         <p:nvSpPr>
-          <p:cNvPr id="4" name="Text 2"/>
+          <p:cNvPr id="4" name="Text 2">
+            <a:extLst>
+              <a:ext uri="{FF2B5EF4-FFF2-40B4-BE49-F238E27FC236}">
+                <a16:creationId xmlns:a16="http://schemas.microsoft.com/office/drawing/2014/main" id="{2A9BCE16-2DC1-49E1-5B52-98374BA0BC0D}"/>
+              </a:ext>
+            </a:extLst>
+          </p:cNvPr>
           <p:cNvSpPr/>
           <p:nvPr/>
         </p:nvSpPr>
@@ -10454,7 +9355,13 @@
       </p:sp>
       <p:pic>
         <p:nvPicPr>
-          <p:cNvPr id="5" name="Image 0" descr="/mnt/data/presentation_assets/phase2_accuracy_refined.png"/>
+          <p:cNvPr id="5" name="Image 0" descr="/mnt/data/presentation_assets/phase2_accuracy_refined.png">
+            <a:extLst>
+              <a:ext uri="{FF2B5EF4-FFF2-40B4-BE49-F238E27FC236}">
+                <a16:creationId xmlns:a16="http://schemas.microsoft.com/office/drawing/2014/main" id="{5A9CD215-EA53-B1BF-0365-3684330BC575}"/>
+              </a:ext>
+            </a:extLst>
+          </p:cNvPr>
           <p:cNvPicPr>
             <a:picLocks noChangeAspect="1"/>
           </p:cNvPicPr>
@@ -10478,7 +9385,13 @@
       </p:pic>
       <p:sp>
         <p:nvSpPr>
-          <p:cNvPr id="6" name="Shape 3"/>
+          <p:cNvPr id="6" name="Shape 3">
+            <a:extLst>
+              <a:ext uri="{FF2B5EF4-FFF2-40B4-BE49-F238E27FC236}">
+                <a16:creationId xmlns:a16="http://schemas.microsoft.com/office/drawing/2014/main" id="{72BD9721-6246-3CF3-1218-646F0F0EAB48}"/>
+              </a:ext>
+            </a:extLst>
+          </p:cNvPr>
           <p:cNvSpPr/>
           <p:nvPr/>
         </p:nvSpPr>
@@ -10512,7 +9425,13 @@
       </p:sp>
       <p:sp>
         <p:nvSpPr>
-          <p:cNvPr id="7" name="Text 4"/>
+          <p:cNvPr id="7" name="Text 4">
+            <a:extLst>
+              <a:ext uri="{FF2B5EF4-FFF2-40B4-BE49-F238E27FC236}">
+                <a16:creationId xmlns:a16="http://schemas.microsoft.com/office/drawing/2014/main" id="{0E4D8860-C2C7-81ED-5F3F-A7E86AB4A4C9}"/>
+              </a:ext>
+            </a:extLst>
+          </p:cNvPr>
           <p:cNvSpPr/>
           <p:nvPr/>
         </p:nvSpPr>
@@ -10548,7 +9467,13 @@
       </p:sp>
       <p:sp>
         <p:nvSpPr>
-          <p:cNvPr id="8" name="Text 5"/>
+          <p:cNvPr id="8" name="Text 5">
+            <a:extLst>
+              <a:ext uri="{FF2B5EF4-FFF2-40B4-BE49-F238E27FC236}">
+                <a16:creationId xmlns:a16="http://schemas.microsoft.com/office/drawing/2014/main" id="{497CB391-2556-EB47-DF7F-CAEDF1592D26}"/>
+              </a:ext>
+            </a:extLst>
+          </p:cNvPr>
           <p:cNvSpPr/>
           <p:nvPr/>
         </p:nvSpPr>
@@ -10598,7 +9523,13 @@
       </p:sp>
       <p:sp>
         <p:nvSpPr>
-          <p:cNvPr id="9" name="Shape 6"/>
+          <p:cNvPr id="9" name="Shape 6">
+            <a:extLst>
+              <a:ext uri="{FF2B5EF4-FFF2-40B4-BE49-F238E27FC236}">
+                <a16:creationId xmlns:a16="http://schemas.microsoft.com/office/drawing/2014/main" id="{2ECE0D3D-5D26-4B9A-57C1-887520FCD88B}"/>
+              </a:ext>
+            </a:extLst>
+          </p:cNvPr>
           <p:cNvSpPr/>
           <p:nvPr/>
         </p:nvSpPr>
@@ -10632,7 +9563,13 @@
       </p:sp>
       <p:sp>
         <p:nvSpPr>
-          <p:cNvPr id="10" name="Text 7"/>
+          <p:cNvPr id="10" name="Text 7">
+            <a:extLst>
+              <a:ext uri="{FF2B5EF4-FFF2-40B4-BE49-F238E27FC236}">
+                <a16:creationId xmlns:a16="http://schemas.microsoft.com/office/drawing/2014/main" id="{EE344F95-38A9-DB0F-6CA2-0CB4DED979E6}"/>
+              </a:ext>
+            </a:extLst>
+          </p:cNvPr>
           <p:cNvSpPr/>
           <p:nvPr/>
         </p:nvSpPr>
@@ -10668,7 +9605,13 @@
       </p:sp>
       <p:sp>
         <p:nvSpPr>
-          <p:cNvPr id="11" name="Text 8"/>
+          <p:cNvPr id="11" name="Text 8">
+            <a:extLst>
+              <a:ext uri="{FF2B5EF4-FFF2-40B4-BE49-F238E27FC236}">
+                <a16:creationId xmlns:a16="http://schemas.microsoft.com/office/drawing/2014/main" id="{2913041D-950E-2970-2B74-06AC0F178320}"/>
+              </a:ext>
+            </a:extLst>
+          </p:cNvPr>
           <p:cNvSpPr/>
           <p:nvPr/>
         </p:nvSpPr>
@@ -10718,7 +9661,13 @@
       </p:sp>
       <p:sp>
         <p:nvSpPr>
-          <p:cNvPr id="12" name="Shape 9"/>
+          <p:cNvPr id="12" name="Shape 9">
+            <a:extLst>
+              <a:ext uri="{FF2B5EF4-FFF2-40B4-BE49-F238E27FC236}">
+                <a16:creationId xmlns:a16="http://schemas.microsoft.com/office/drawing/2014/main" id="{E1C5FA01-7A78-D43F-987A-0BD74A249CB9}"/>
+              </a:ext>
+            </a:extLst>
+          </p:cNvPr>
           <p:cNvSpPr/>
           <p:nvPr/>
         </p:nvSpPr>
@@ -10752,7 +9701,13 @@
       </p:sp>
       <p:sp>
         <p:nvSpPr>
-          <p:cNvPr id="13" name="Text 10"/>
+          <p:cNvPr id="13" name="Text 10">
+            <a:extLst>
+              <a:ext uri="{FF2B5EF4-FFF2-40B4-BE49-F238E27FC236}">
+                <a16:creationId xmlns:a16="http://schemas.microsoft.com/office/drawing/2014/main" id="{6EEAC21E-FEF7-5283-8DED-43BC05082BF7}"/>
+              </a:ext>
+            </a:extLst>
+          </p:cNvPr>
           <p:cNvSpPr/>
           <p:nvPr/>
         </p:nvSpPr>
@@ -10788,7 +9743,13 @@
       </p:sp>
       <p:sp>
         <p:nvSpPr>
-          <p:cNvPr id="14" name="Text 11"/>
+          <p:cNvPr id="14" name="Text 11">
+            <a:extLst>
+              <a:ext uri="{FF2B5EF4-FFF2-40B4-BE49-F238E27FC236}">
+                <a16:creationId xmlns:a16="http://schemas.microsoft.com/office/drawing/2014/main" id="{9C823F2A-CCB8-621B-2A89-9A315CDA7E5A}"/>
+              </a:ext>
+            </a:extLst>
+          </p:cNvPr>
           <p:cNvSpPr/>
           <p:nvPr/>
         </p:nvSpPr>
@@ -10838,7 +9799,13 @@
       </p:sp>
       <p:sp>
         <p:nvSpPr>
-          <p:cNvPr id="15" name="Shape 12"/>
+          <p:cNvPr id="15" name="Shape 12">
+            <a:extLst>
+              <a:ext uri="{FF2B5EF4-FFF2-40B4-BE49-F238E27FC236}">
+                <a16:creationId xmlns:a16="http://schemas.microsoft.com/office/drawing/2014/main" id="{99F3BDBA-C330-D180-39AB-85855C87C39E}"/>
+              </a:ext>
+            </a:extLst>
+          </p:cNvPr>
           <p:cNvSpPr/>
           <p:nvPr/>
         </p:nvSpPr>
@@ -10872,7 +9839,13 @@
       </p:sp>
       <p:sp>
         <p:nvSpPr>
-          <p:cNvPr id="16" name="Text 13"/>
+          <p:cNvPr id="16" name="Text 13">
+            <a:extLst>
+              <a:ext uri="{FF2B5EF4-FFF2-40B4-BE49-F238E27FC236}">
+                <a16:creationId xmlns:a16="http://schemas.microsoft.com/office/drawing/2014/main" id="{7336FE8E-95F7-64D1-C7A9-8E788276F49F}"/>
+              </a:ext>
+            </a:extLst>
+          </p:cNvPr>
           <p:cNvSpPr/>
           <p:nvPr/>
         </p:nvSpPr>
@@ -10908,7 +9881,13 @@
       </p:sp>
       <p:sp>
         <p:nvSpPr>
-          <p:cNvPr id="17" name="Text 14"/>
+          <p:cNvPr id="17" name="Text 14">
+            <a:extLst>
+              <a:ext uri="{FF2B5EF4-FFF2-40B4-BE49-F238E27FC236}">
+                <a16:creationId xmlns:a16="http://schemas.microsoft.com/office/drawing/2014/main" id="{98AFD95F-1218-50F0-1A27-B80607F594A3}"/>
+              </a:ext>
+            </a:extLst>
+          </p:cNvPr>
           <p:cNvSpPr/>
           <p:nvPr/>
         </p:nvSpPr>
@@ -10958,7 +9937,13 @@
       </p:sp>
       <p:sp>
         <p:nvSpPr>
-          <p:cNvPr id="19" name="Text 16"/>
+          <p:cNvPr id="19" name="Text 16">
+            <a:extLst>
+              <a:ext uri="{FF2B5EF4-FFF2-40B4-BE49-F238E27FC236}">
+                <a16:creationId xmlns:a16="http://schemas.microsoft.com/office/drawing/2014/main" id="{054D178F-7125-E06B-777D-0C4B8F2B1D0C}"/>
+              </a:ext>
+            </a:extLst>
+          </p:cNvPr>
           <p:cNvSpPr/>
           <p:nvPr/>
         </p:nvSpPr>
@@ -10996,6 +9981,11 @@
         </p:txBody>
       </p:sp>
     </p:spTree>
+    <p:extLst>
+      <p:ext uri="{BB962C8B-B14F-4D97-AF65-F5344CB8AC3E}">
+        <p14:creationId xmlns:p14="http://schemas.microsoft.com/office/powerpoint/2010/main" val="1549715193"/>
+      </p:ext>
+    </p:extLst>
   </p:cSld>
   <p:clrMapOvr>
     <a:masterClrMapping/>
@@ -12316,7 +11306,7 @@
         </p:blipFill>
         <p:spPr>
           <a:xfrm>
-            <a:off x="777240" y="1446896"/>
+            <a:off x="822960" y="1864661"/>
             <a:ext cx="7040880" cy="3598448"/>
           </a:xfrm>
           <a:prstGeom prst="rect">
@@ -12332,7 +11322,7 @@
         </p:nvSpPr>
         <p:spPr>
           <a:xfrm>
-            <a:off x="8001000" y="1325880"/>
+            <a:off x="8046720" y="1743645"/>
             <a:ext cx="1448410" cy="632460"/>
           </a:xfrm>
           <a:prstGeom prst="rect">
@@ -12364,7 +11354,7 @@
         </p:nvSpPr>
         <p:spPr>
           <a:xfrm>
-            <a:off x="8055864" y="1362456"/>
+            <a:off x="8101584" y="1780221"/>
             <a:ext cx="1338682" cy="559308"/>
           </a:xfrm>
           <a:prstGeom prst="rect">
@@ -12402,7 +11392,7 @@
         </p:nvSpPr>
         <p:spPr>
           <a:xfrm>
-            <a:off x="9449410" y="1325880"/>
+            <a:off x="9495130" y="1743645"/>
             <a:ext cx="921715" cy="632460"/>
           </a:xfrm>
           <a:prstGeom prst="rect">
@@ -12434,7 +11424,7 @@
         </p:nvSpPr>
         <p:spPr>
           <a:xfrm>
-            <a:off x="9504274" y="1362456"/>
+            <a:off x="9549994" y="1780221"/>
             <a:ext cx="811987" cy="559308"/>
           </a:xfrm>
           <a:prstGeom prst="rect">
@@ -12472,7 +11462,7 @@
         </p:nvSpPr>
         <p:spPr>
           <a:xfrm>
-            <a:off x="10371125" y="1325880"/>
+            <a:off x="10416845" y="1743645"/>
             <a:ext cx="921715" cy="632460"/>
           </a:xfrm>
           <a:prstGeom prst="rect">
@@ -12504,7 +11494,7 @@
         </p:nvSpPr>
         <p:spPr>
           <a:xfrm>
-            <a:off x="10425989" y="1362456"/>
+            <a:off x="10471709" y="1780221"/>
             <a:ext cx="811987" cy="559308"/>
           </a:xfrm>
           <a:prstGeom prst="rect">
@@ -12542,7 +11532,7 @@
         </p:nvSpPr>
         <p:spPr>
           <a:xfrm>
-            <a:off x="8001000" y="1958340"/>
+            <a:off x="8046720" y="2376105"/>
             <a:ext cx="1448410" cy="632460"/>
           </a:xfrm>
           <a:prstGeom prst="rect">
@@ -12574,7 +11564,7 @@
         </p:nvSpPr>
         <p:spPr>
           <a:xfrm>
-            <a:off x="8055864" y="1994916"/>
+            <a:off x="8101584" y="2412681"/>
             <a:ext cx="1338682" cy="559308"/>
           </a:xfrm>
           <a:prstGeom prst="rect">
@@ -12612,7 +11602,7 @@
         </p:nvSpPr>
         <p:spPr>
           <a:xfrm>
-            <a:off x="9449410" y="1958340"/>
+            <a:off x="9495130" y="2376105"/>
             <a:ext cx="921715" cy="632460"/>
           </a:xfrm>
           <a:prstGeom prst="rect">
@@ -12644,7 +11634,7 @@
         </p:nvSpPr>
         <p:spPr>
           <a:xfrm>
-            <a:off x="9504274" y="1994916"/>
+            <a:off x="9549994" y="2412681"/>
             <a:ext cx="811987" cy="559308"/>
           </a:xfrm>
           <a:prstGeom prst="rect">
@@ -12682,7 +11672,7 @@
         </p:nvSpPr>
         <p:spPr>
           <a:xfrm>
-            <a:off x="10371125" y="1958340"/>
+            <a:off x="10416845" y="2376105"/>
             <a:ext cx="921715" cy="632460"/>
           </a:xfrm>
           <a:prstGeom prst="rect">
@@ -12714,7 +11704,7 @@
         </p:nvSpPr>
         <p:spPr>
           <a:xfrm>
-            <a:off x="10425989" y="1994916"/>
+            <a:off x="10471709" y="2412681"/>
             <a:ext cx="811987" cy="559308"/>
           </a:xfrm>
           <a:prstGeom prst="rect">
@@ -12752,7 +11742,7 @@
         </p:nvSpPr>
         <p:spPr>
           <a:xfrm>
-            <a:off x="8001000" y="2590800"/>
+            <a:off x="8046720" y="3008565"/>
             <a:ext cx="1448410" cy="632460"/>
           </a:xfrm>
           <a:prstGeom prst="rect">
@@ -12784,7 +11774,7 @@
         </p:nvSpPr>
         <p:spPr>
           <a:xfrm>
-            <a:off x="8055864" y="2627376"/>
+            <a:off x="8101584" y="3045141"/>
             <a:ext cx="1338682" cy="559308"/>
           </a:xfrm>
           <a:prstGeom prst="rect">
@@ -12822,7 +11812,7 @@
         </p:nvSpPr>
         <p:spPr>
           <a:xfrm>
-            <a:off x="9449410" y="2590800"/>
+            <a:off x="9495130" y="3008565"/>
             <a:ext cx="921715" cy="632460"/>
           </a:xfrm>
           <a:prstGeom prst="rect">
@@ -12854,7 +11844,7 @@
         </p:nvSpPr>
         <p:spPr>
           <a:xfrm>
-            <a:off x="9504274" y="2627376"/>
+            <a:off x="9549994" y="3045141"/>
             <a:ext cx="811987" cy="559308"/>
           </a:xfrm>
           <a:prstGeom prst="rect">
@@ -12892,7 +11882,7 @@
         </p:nvSpPr>
         <p:spPr>
           <a:xfrm>
-            <a:off x="10371125" y="2590800"/>
+            <a:off x="10416845" y="3008565"/>
             <a:ext cx="921715" cy="632460"/>
           </a:xfrm>
           <a:prstGeom prst="rect">
@@ -12924,7 +11914,7 @@
         </p:nvSpPr>
         <p:spPr>
           <a:xfrm>
-            <a:off x="10425989" y="2627376"/>
+            <a:off x="10471709" y="3045141"/>
             <a:ext cx="811987" cy="559308"/>
           </a:xfrm>
           <a:prstGeom prst="rect">
@@ -12962,7 +11952,7 @@
         </p:nvSpPr>
         <p:spPr>
           <a:xfrm>
-            <a:off x="8001000" y="3223260"/>
+            <a:off x="8046720" y="3641025"/>
             <a:ext cx="1448410" cy="632460"/>
           </a:xfrm>
           <a:prstGeom prst="rect">
@@ -12994,7 +11984,7 @@
         </p:nvSpPr>
         <p:spPr>
           <a:xfrm>
-            <a:off x="8055864" y="3259836"/>
+            <a:off x="8101584" y="3677601"/>
             <a:ext cx="1338682" cy="559308"/>
           </a:xfrm>
           <a:prstGeom prst="rect">
@@ -13032,7 +12022,7 @@
         </p:nvSpPr>
         <p:spPr>
           <a:xfrm>
-            <a:off x="9449410" y="3223260"/>
+            <a:off x="9495130" y="3641025"/>
             <a:ext cx="921715" cy="632460"/>
           </a:xfrm>
           <a:prstGeom prst="rect">
@@ -13064,7 +12054,7 @@
         </p:nvSpPr>
         <p:spPr>
           <a:xfrm>
-            <a:off x="9504274" y="3259836"/>
+            <a:off x="9549994" y="3677601"/>
             <a:ext cx="811987" cy="559308"/>
           </a:xfrm>
           <a:prstGeom prst="rect">
@@ -13102,7 +12092,7 @@
         </p:nvSpPr>
         <p:spPr>
           <a:xfrm>
-            <a:off x="10371125" y="3223260"/>
+            <a:off x="10416845" y="3641025"/>
             <a:ext cx="921715" cy="632460"/>
           </a:xfrm>
           <a:prstGeom prst="rect">
@@ -13134,7 +12124,7 @@
         </p:nvSpPr>
         <p:spPr>
           <a:xfrm>
-            <a:off x="10425989" y="3259836"/>
+            <a:off x="10471709" y="3677601"/>
             <a:ext cx="811987" cy="559308"/>
           </a:xfrm>
           <a:prstGeom prst="rect">
@@ -13172,7 +12162,7 @@
         </p:nvSpPr>
         <p:spPr>
           <a:xfrm>
-            <a:off x="8001000" y="3855720"/>
+            <a:off x="8046720" y="4273485"/>
             <a:ext cx="1448410" cy="632460"/>
           </a:xfrm>
           <a:prstGeom prst="rect">
@@ -13204,7 +12194,7 @@
         </p:nvSpPr>
         <p:spPr>
           <a:xfrm>
-            <a:off x="8055864" y="3892296"/>
+            <a:off x="8101584" y="4310061"/>
             <a:ext cx="1338682" cy="559308"/>
           </a:xfrm>
           <a:prstGeom prst="rect">
@@ -13242,7 +12232,7 @@
         </p:nvSpPr>
         <p:spPr>
           <a:xfrm>
-            <a:off x="9449410" y="3855720"/>
+            <a:off x="9495130" y="4273485"/>
             <a:ext cx="921715" cy="632460"/>
           </a:xfrm>
           <a:prstGeom prst="rect">
@@ -13274,7 +12264,7 @@
         </p:nvSpPr>
         <p:spPr>
           <a:xfrm>
-            <a:off x="9504274" y="3892296"/>
+            <a:off x="9549994" y="4310061"/>
             <a:ext cx="811987" cy="559308"/>
           </a:xfrm>
           <a:prstGeom prst="rect">
@@ -13312,7 +12302,7 @@
         </p:nvSpPr>
         <p:spPr>
           <a:xfrm>
-            <a:off x="10371125" y="3855720"/>
+            <a:off x="10416845" y="4273485"/>
             <a:ext cx="921715" cy="632460"/>
           </a:xfrm>
           <a:prstGeom prst="rect">
@@ -13344,7 +12334,7 @@
         </p:nvSpPr>
         <p:spPr>
           <a:xfrm>
-            <a:off x="10425989" y="3892296"/>
+            <a:off x="10471709" y="4310061"/>
             <a:ext cx="811987" cy="559308"/>
           </a:xfrm>
           <a:prstGeom prst="rect">
@@ -13382,7 +12372,7 @@
         </p:nvSpPr>
         <p:spPr>
           <a:xfrm>
-            <a:off x="8001000" y="4488180"/>
+            <a:off x="8046720" y="4905945"/>
             <a:ext cx="1448410" cy="632460"/>
           </a:xfrm>
           <a:prstGeom prst="rect">
@@ -13414,7 +12404,7 @@
         </p:nvSpPr>
         <p:spPr>
           <a:xfrm>
-            <a:off x="8055864" y="4524756"/>
+            <a:off x="8101584" y="4942521"/>
             <a:ext cx="1338682" cy="559308"/>
           </a:xfrm>
           <a:prstGeom prst="rect">
@@ -13452,7 +12442,7 @@
         </p:nvSpPr>
         <p:spPr>
           <a:xfrm>
-            <a:off x="9449410" y="4488180"/>
+            <a:off x="9495130" y="4905945"/>
             <a:ext cx="921715" cy="632460"/>
           </a:xfrm>
           <a:prstGeom prst="rect">
@@ -13484,7 +12474,7 @@
         </p:nvSpPr>
         <p:spPr>
           <a:xfrm>
-            <a:off x="9504274" y="4524756"/>
+            <a:off x="9549994" y="4942521"/>
             <a:ext cx="811987" cy="559308"/>
           </a:xfrm>
           <a:prstGeom prst="rect">
@@ -13522,7 +12512,7 @@
         </p:nvSpPr>
         <p:spPr>
           <a:xfrm>
-            <a:off x="10371125" y="4488180"/>
+            <a:off x="10416845" y="4905945"/>
             <a:ext cx="921715" cy="632460"/>
           </a:xfrm>
           <a:prstGeom prst="rect">
@@ -13554,7 +12544,7 @@
         </p:nvSpPr>
         <p:spPr>
           <a:xfrm>
-            <a:off x="10425989" y="4524756"/>
+            <a:off x="10471709" y="4942521"/>
             <a:ext cx="811987" cy="559308"/>
           </a:xfrm>
           <a:prstGeom prst="rect">

</xml_diff>